<commit_message>
Movers slides: three stores per column (round 51)
Co-Authored-By: Claude Opus 5.5 <noreply@anthropic.com>
Claude-Session: https://claude.ai/code/session_01Xa4nFVxuQGXmHARGph9WhS
</commit_message>
<xml_diff>
--- a/day2-deck/decks/Labor Mix - House Style.pptx
+++ b/day2-deck/decks/Labor Mix - House Style.pptx
@@ -2762,7 +2762,7 @@
           <a:p>
             <a:r>
               <a:rPr lang="en-US" dirty="0"/>
-              <a:t>Takeaway with the store call-outs (off the slide): Ask Mazda, VW Henderson and Acura what changed. Ask LR Reno, Hyundai Prescott and Toyota Henderson what got in the way. Ask Lexus, Acura and Chevy GMC Bullhead what they started this year.Source: Qlik - Closed Repair Orders. Labor sale by pay type, Jan-Sep by close month. Same-store, INEOS excluded. GMC Prescott body shop labor types excluded. Customer-pay labor sale / total labor sale (customer pay + warranty + internal). Top and bottom five stores by change in Customer Pay Share of Labor Sale, Jan-Sep 2026 vs 2025. Moving now: Jul-Sep 2026 vs Jan-Mar 2026, each store against itself; the group moved −0.3 pts on the same basis, so part of every store's change is seasonal. Green bar at the right of a row: the store is on both the top five vs last year and the top five moving now. Blue bar: a turnaround, on the bottom five vs last year and the top five moving now.Conversation starter: each top store says one thing they started doing; each bottom store says what got in the way and what they would try. The room trades ideas. Moving now: ask the top three what they started this year.</a:t>
+              <a:t>Takeaway with the store call-outs (off the slide): Ask Mazda, VW Henderson and Acura what changed. Ask LR Reno, Hyundai Prescott and Toyota Henderson what got in the way. Ask Lexus, Acura and Chevy GMC Bullhead what they started this year.Source: Qlik - Closed Repair Orders. Labor sale by pay type, Jan-Sep by close month. Same-store, INEOS excluded. GMC Prescott body shop labor types excluded. Customer-pay labor sale / total labor sale (customer pay + warranty + internal). Top and bottom three stores by change in Customer Pay Share of Labor Sale, Jan-Sep 2026 vs 2025. Moving now: Jul-Sep 2026 vs Jan-Mar 2026, each store against itself; the group moved −0.3 pts on the same basis, so part of every store's change is seasonal. Green bar at the right of a row: the store is on both the top three vs last year and the top three moving now. Blue bar: a turnaround, on the bottom three vs last year and the top three moving now.Conversation starter: each top store says one thing they started doing; each bottom store says what got in the way and what they would try. The room trades ideas. Moving now: ask the top three what they started this year.</a:t>
             </a:r>
             <a:endParaRPr lang="en-US" dirty="0"/>
           </a:p>
@@ -17725,7 +17725,7 @@
                 <a:ea typeface="Inter" pitchFamily="34" charset="-122"/>
                 <a:cs typeface="Inter" pitchFamily="34" charset="-120"/>
               </a:rPr>
-              <a:t>TOP 5 VS LAST YEAR</a:t>
+              <a:t>TOP 3 VS LAST YEAR</a:t>
             </a:r>
             <a:endParaRPr lang="en-US" sz="1500" dirty="0"/>
           </a:p>
@@ -17779,7 +17779,7 @@
         <p:spPr>
           <a:xfrm>
             <a:off x="658368" y="2103120"/>
-            <a:ext cx="3489960" cy="828446"/>
+            <a:ext cx="3489960" cy="1380744"/>
           </a:xfrm>
           <a:prstGeom prst="rect">
             <a:avLst/>
@@ -17799,7 +17799,7 @@
         <p:spPr>
           <a:xfrm>
             <a:off x="749808" y="2103120"/>
-            <a:ext cx="365760" cy="828446"/>
+            <a:ext cx="365760" cy="1380744"/>
           </a:xfrm>
           <a:prstGeom prst="rect">
             <a:avLst/>
@@ -17815,7 +17815,7 @@
               <a:buNone/>
             </a:pPr>
             <a:r>
-              <a:rPr lang="en-US" sz="1500" b="1" dirty="0">
+              <a:rPr lang="en-US" sz="2000" b="1" dirty="0">
                 <a:solidFill>
                   <a:srgbClr val="0B2C4A"/>
                 </a:solidFill>
@@ -17825,7 +17825,7 @@
               </a:rPr>
               <a:t>1</a:t>
             </a:r>
-            <a:endParaRPr lang="en-US" sz="1500" dirty="0"/>
+            <a:endParaRPr lang="en-US" sz="2000" dirty="0"/>
           </a:p>
         </p:txBody>
       </p:sp>
@@ -17837,8 +17837,8 @@
         </p:nvSpPr>
         <p:spPr>
           <a:xfrm>
-            <a:off x="1097280" y="2103120"/>
-            <a:ext cx="1825752" cy="828446"/>
+            <a:off x="1161288" y="2103120"/>
+            <a:ext cx="1917192" cy="1380744"/>
           </a:xfrm>
           <a:prstGeom prst="rect">
             <a:avLst/>
@@ -17857,7 +17857,7 @@
               <a:buNone/>
             </a:pPr>
             <a:r>
-              <a:rPr lang="en-US" sz="1400" b="1" dirty="0">
+              <a:rPr lang="en-US" sz="1700" b="1" dirty="0">
                 <a:solidFill>
                   <a:srgbClr val="1A1A1A"/>
                 </a:solidFill>
@@ -17867,7 +17867,7 @@
               </a:rPr>
               <a:t>Mazda</a:t>
             </a:r>
-            <a:endParaRPr lang="en-US" sz="1400" dirty="0"/>
+            <a:endParaRPr lang="en-US" sz="1700" dirty="0"/>
           </a:p>
           <a:p>
             <a:pPr indent="0" marL="0">
@@ -17877,7 +17877,7 @@
               <a:buNone/>
             </a:pPr>
             <a:r>
-              <a:rPr lang="en-US" sz="1200" dirty="0">
+              <a:rPr lang="en-US" sz="1400" dirty="0">
                 <a:solidFill>
                   <a:srgbClr val="595959"/>
                 </a:solidFill>
@@ -17894,7 +17894,7 @@
               <a:buNone/>
             </a:pPr>
             <a:r>
-              <a:rPr lang="en-US" sz="1200" b="1" dirty="0">
+              <a:rPr lang="en-US" sz="1400" b="1" dirty="0">
                 <a:solidFill>
                   <a:srgbClr val="0B7A4A"/>
                 </a:solidFill>
@@ -17904,7 +17904,7 @@
               </a:rPr>
               <a:t>56.6%</a:t>
             </a:r>
-            <a:endParaRPr lang="en-US" sz="1400" dirty="0"/>
+            <a:endParaRPr lang="en-US" sz="1700" dirty="0"/>
           </a:p>
         </p:txBody>
       </p:sp>
@@ -17916,8 +17916,8 @@
         </p:nvSpPr>
         <p:spPr>
           <a:xfrm>
-            <a:off x="2941320" y="2103120"/>
-            <a:ext cx="1115568" cy="828446"/>
+            <a:off x="3124200" y="2103120"/>
+            <a:ext cx="932688" cy="1380744"/>
           </a:xfrm>
           <a:prstGeom prst="rect">
             <a:avLst/>
@@ -17933,7 +17933,7 @@
               <a:buNone/>
             </a:pPr>
             <a:r>
-              <a:rPr lang="en-US" sz="1600" b="1" dirty="0">
+              <a:rPr lang="en-US" sz="1800" b="1" dirty="0">
                 <a:solidFill>
                   <a:srgbClr val="0B7A4A"/>
                 </a:solidFill>
@@ -17943,7 +17943,7 @@
               </a:rPr>
               <a:t>+10.8 pts</a:t>
             </a:r>
-            <a:endParaRPr lang="en-US" sz="1600" dirty="0"/>
+            <a:endParaRPr lang="en-US" sz="1800" dirty="0"/>
           </a:p>
         </p:txBody>
       </p:sp>
@@ -17955,8 +17955,8 @@
         </p:nvSpPr>
         <p:spPr>
           <a:xfrm>
-            <a:off x="749808" y="2931566"/>
-            <a:ext cx="365760" cy="828446"/>
+            <a:off x="749808" y="3483864"/>
+            <a:ext cx="365760" cy="1380744"/>
           </a:xfrm>
           <a:prstGeom prst="rect">
             <a:avLst/>
@@ -17972,7 +17972,7 @@
               <a:buNone/>
             </a:pPr>
             <a:r>
-              <a:rPr lang="en-US" sz="1500" b="1" dirty="0">
+              <a:rPr lang="en-US" sz="2000" b="1" dirty="0">
                 <a:solidFill>
                   <a:srgbClr val="0B2C4A"/>
                 </a:solidFill>
@@ -17982,7 +17982,7 @@
               </a:rPr>
               <a:t>2</a:t>
             </a:r>
-            <a:endParaRPr lang="en-US" sz="1500" dirty="0"/>
+            <a:endParaRPr lang="en-US" sz="2000" dirty="0"/>
           </a:p>
         </p:txBody>
       </p:sp>
@@ -17994,8 +17994,8 @@
         </p:nvSpPr>
         <p:spPr>
           <a:xfrm>
-            <a:off x="1097280" y="2931566"/>
-            <a:ext cx="1825752" cy="828446"/>
+            <a:off x="1161288" y="3483864"/>
+            <a:ext cx="1917192" cy="1380744"/>
           </a:xfrm>
           <a:prstGeom prst="rect">
             <a:avLst/>
@@ -18014,7 +18014,7 @@
               <a:buNone/>
             </a:pPr>
             <a:r>
-              <a:rPr lang="en-US" sz="1400" b="1" dirty="0">
+              <a:rPr lang="en-US" sz="1700" b="1" dirty="0">
                 <a:solidFill>
                   <a:srgbClr val="1A1A1A"/>
                 </a:solidFill>
@@ -18024,7 +18024,7 @@
               </a:rPr>
               <a:t>VW Henderson</a:t>
             </a:r>
-            <a:endParaRPr lang="en-US" sz="1400" dirty="0"/>
+            <a:endParaRPr lang="en-US" sz="1700" dirty="0"/>
           </a:p>
           <a:p>
             <a:pPr indent="0" marL="0">
@@ -18034,7 +18034,7 @@
               <a:buNone/>
             </a:pPr>
             <a:r>
-              <a:rPr lang="en-US" sz="1200" dirty="0">
+              <a:rPr lang="en-US" sz="1400" dirty="0">
                 <a:solidFill>
                   <a:srgbClr val="595959"/>
                 </a:solidFill>
@@ -18051,7 +18051,7 @@
               <a:buNone/>
             </a:pPr>
             <a:r>
-              <a:rPr lang="en-US" sz="1200" b="1" dirty="0">
+              <a:rPr lang="en-US" sz="1400" b="1" dirty="0">
                 <a:solidFill>
                   <a:srgbClr val="0B7A4A"/>
                 </a:solidFill>
@@ -18061,7 +18061,7 @@
               </a:rPr>
               <a:t>47.2%</a:t>
             </a:r>
-            <a:endParaRPr lang="en-US" sz="1400" dirty="0"/>
+            <a:endParaRPr lang="en-US" sz="1700" dirty="0"/>
           </a:p>
         </p:txBody>
       </p:sp>
@@ -18073,8 +18073,8 @@
         </p:nvSpPr>
         <p:spPr>
           <a:xfrm>
-            <a:off x="2941320" y="2931566"/>
-            <a:ext cx="1115568" cy="828446"/>
+            <a:off x="3124200" y="3483864"/>
+            <a:ext cx="932688" cy="1380744"/>
           </a:xfrm>
           <a:prstGeom prst="rect">
             <a:avLst/>
@@ -18090,7 +18090,7 @@
               <a:buNone/>
             </a:pPr>
             <a:r>
-              <a:rPr lang="en-US" sz="1600" b="1" dirty="0">
+              <a:rPr lang="en-US" sz="1800" b="1" dirty="0">
                 <a:solidFill>
                   <a:srgbClr val="0B7A4A"/>
                 </a:solidFill>
@@ -18100,7 +18100,7 @@
               </a:rPr>
               <a:t>+9.8 pts</a:t>
             </a:r>
-            <a:endParaRPr lang="en-US" sz="1600" dirty="0"/>
+            <a:endParaRPr lang="en-US" sz="1800" dirty="0"/>
           </a:p>
         </p:txBody>
       </p:sp>
@@ -18112,8 +18112,8 @@
         </p:nvSpPr>
         <p:spPr>
           <a:xfrm>
-            <a:off x="658368" y="3760013"/>
-            <a:ext cx="3489960" cy="828446"/>
+            <a:off x="658368" y="4864608"/>
+            <a:ext cx="3489960" cy="1380744"/>
           </a:xfrm>
           <a:prstGeom prst="rect">
             <a:avLst/>
@@ -18132,8 +18132,8 @@
         </p:nvSpPr>
         <p:spPr>
           <a:xfrm>
-            <a:off x="4084320" y="3796589"/>
-            <a:ext cx="64008" cy="755294"/>
+            <a:off x="4084320" y="4901184"/>
+            <a:ext cx="64008" cy="1307592"/>
           </a:xfrm>
           <a:prstGeom prst="rect">
             <a:avLst/>
@@ -18152,8 +18152,8 @@
         </p:nvSpPr>
         <p:spPr>
           <a:xfrm>
-            <a:off x="749808" y="3760013"/>
-            <a:ext cx="365760" cy="828446"/>
+            <a:off x="749808" y="4864608"/>
+            <a:ext cx="365760" cy="1380744"/>
           </a:xfrm>
           <a:prstGeom prst="rect">
             <a:avLst/>
@@ -18169,7 +18169,7 @@
               <a:buNone/>
             </a:pPr>
             <a:r>
-              <a:rPr lang="en-US" sz="1500" b="1" dirty="0">
+              <a:rPr lang="en-US" sz="2000" b="1" dirty="0">
                 <a:solidFill>
                   <a:srgbClr val="0B2C4A"/>
                 </a:solidFill>
@@ -18179,7 +18179,7 @@
               </a:rPr>
               <a:t>3</a:t>
             </a:r>
-            <a:endParaRPr lang="en-US" sz="1500" dirty="0"/>
+            <a:endParaRPr lang="en-US" sz="2000" dirty="0"/>
           </a:p>
         </p:txBody>
       </p:sp>
@@ -18191,8 +18191,8 @@
         </p:nvSpPr>
         <p:spPr>
           <a:xfrm>
-            <a:off x="1097280" y="3760013"/>
-            <a:ext cx="1825752" cy="828446"/>
+            <a:off x="1161288" y="4864608"/>
+            <a:ext cx="1917192" cy="1380744"/>
           </a:xfrm>
           <a:prstGeom prst="rect">
             <a:avLst/>
@@ -18211,7 +18211,7 @@
               <a:buNone/>
             </a:pPr>
             <a:r>
-              <a:rPr lang="en-US" sz="1400" b="1" dirty="0">
+              <a:rPr lang="en-US" sz="1700" b="1" dirty="0">
                 <a:solidFill>
                   <a:srgbClr val="1A1A1A"/>
                 </a:solidFill>
@@ -18221,7 +18221,7 @@
               </a:rPr>
               <a:t>Acura</a:t>
             </a:r>
-            <a:endParaRPr lang="en-US" sz="1400" dirty="0"/>
+            <a:endParaRPr lang="en-US" sz="1700" dirty="0"/>
           </a:p>
           <a:p>
             <a:pPr indent="0" marL="0">
@@ -18231,7 +18231,7 @@
               <a:buNone/>
             </a:pPr>
             <a:r>
-              <a:rPr lang="en-US" sz="1200" dirty="0">
+              <a:rPr lang="en-US" sz="1400" dirty="0">
                 <a:solidFill>
                   <a:srgbClr val="595959"/>
                 </a:solidFill>
@@ -18248,7 +18248,7 @@
               <a:buNone/>
             </a:pPr>
             <a:r>
-              <a:rPr lang="en-US" sz="1200" b="1" dirty="0">
+              <a:rPr lang="en-US" sz="1400" b="1" dirty="0">
                 <a:solidFill>
                   <a:srgbClr val="0B7A4A"/>
                 </a:solidFill>
@@ -18258,7 +18258,7 @@
               </a:rPr>
               <a:t>48.7%</a:t>
             </a:r>
-            <a:endParaRPr lang="en-US" sz="1400" dirty="0"/>
+            <a:endParaRPr lang="en-US" sz="1700" dirty="0"/>
           </a:p>
         </p:txBody>
       </p:sp>
@@ -18270,8 +18270,8 @@
         </p:nvSpPr>
         <p:spPr>
           <a:xfrm>
-            <a:off x="2941320" y="3760013"/>
-            <a:ext cx="1115568" cy="828446"/>
+            <a:off x="3124200" y="4864608"/>
+            <a:ext cx="932688" cy="1380744"/>
           </a:xfrm>
           <a:prstGeom prst="rect">
             <a:avLst/>
@@ -18287,7 +18287,7 @@
               <a:buNone/>
             </a:pPr>
             <a:r>
-              <a:rPr lang="en-US" sz="1600" b="1" dirty="0">
+              <a:rPr lang="en-US" sz="1800" b="1" dirty="0">
                 <a:solidFill>
                   <a:srgbClr val="0B7A4A"/>
                 </a:solidFill>
@@ -18297,20 +18297,40 @@
               </a:rPr>
               <a:t>+9.5 pts</a:t>
             </a:r>
-            <a:endParaRPr lang="en-US" sz="1600" dirty="0"/>
-          </a:p>
-        </p:txBody>
-      </p:sp>
-      <p:sp>
-        <p:nvSpPr>
-          <p:cNvPr id="21" name="Text 19"/>
-          <p:cNvSpPr txBox="1"/>
-          <p:nvPr/>
-        </p:nvSpPr>
-        <p:spPr>
-          <a:xfrm>
-            <a:off x="749808" y="4588459"/>
-            <a:ext cx="365760" cy="828446"/>
+            <a:endParaRPr lang="en-US" sz="1800" dirty="0"/>
+          </a:p>
+        </p:txBody>
+      </p:sp>
+      <p:sp>
+        <p:nvSpPr>
+          <p:cNvPr id="21" name="Shape 19"/>
+          <p:cNvSpPr/>
+          <p:nvPr/>
+        </p:nvSpPr>
+        <p:spPr>
+          <a:xfrm>
+            <a:off x="4349496" y="1371600"/>
+            <a:ext cx="3489960" cy="45720"/>
+          </a:xfrm>
+          <a:prstGeom prst="rect">
+            <a:avLst/>
+          </a:prstGeom>
+          <a:solidFill>
+            <a:srgbClr val="C2352F"/>
+          </a:solidFill>
+          <a:ln/>
+        </p:spPr>
+      </p:sp>
+      <p:sp>
+        <p:nvSpPr>
+          <p:cNvPr id="22" name="Text 20"/>
+          <p:cNvSpPr txBox="1"/>
+          <p:nvPr/>
+        </p:nvSpPr>
+        <p:spPr>
+          <a:xfrm>
+            <a:off x="4440936" y="1444752"/>
+            <a:ext cx="3307080" cy="274320"/>
           </a:xfrm>
           <a:prstGeom prst="rect">
             <a:avLst/>
@@ -18326,7 +18346,105 @@
               <a:buNone/>
             </a:pPr>
             <a:r>
-              <a:rPr lang="en-US" sz="1500" b="1" dirty="0">
+              <a:rPr lang="en-US" sz="1500" b="1" spc="100" kern="0" dirty="0">
+                <a:solidFill>
+                  <a:srgbClr val="A82B26"/>
+                </a:solidFill>
+                <a:latin typeface="Inter" pitchFamily="34" charset="0"/>
+                <a:ea typeface="Inter" pitchFamily="34" charset="-122"/>
+                <a:cs typeface="Inter" pitchFamily="34" charset="-120"/>
+              </a:rPr>
+              <a:t>BOTTOM 3 VS LAST YEAR</a:t>
+            </a:r>
+            <a:endParaRPr lang="en-US" sz="1500" dirty="0"/>
+          </a:p>
+        </p:txBody>
+      </p:sp>
+      <p:sp>
+        <p:nvSpPr>
+          <p:cNvPr id="23" name="Text 21"/>
+          <p:cNvSpPr txBox="1"/>
+          <p:nvPr/>
+        </p:nvSpPr>
+        <p:spPr>
+          <a:xfrm>
+            <a:off x="4440936" y="1737360"/>
+            <a:ext cx="3307080" cy="274320"/>
+          </a:xfrm>
+          <a:prstGeom prst="rect">
+            <a:avLst/>
+          </a:prstGeom>
+          <a:noFill/>
+          <a:ln/>
+        </p:spPr>
+        <p:txBody>
+          <a:bodyPr wrap="square" lIns="0" tIns="0" rIns="0" bIns="0" rtlCol="0" anchor="ctr"/>
+          <a:lstStyle/>
+          <a:p>
+            <a:pPr indent="0" marL="0">
+              <a:buNone/>
+            </a:pPr>
+            <a:r>
+              <a:rPr lang="en-US" sz="1200" dirty="0">
+                <a:solidFill>
+                  <a:srgbClr val="595959"/>
+                </a:solidFill>
+                <a:latin typeface="Inter" pitchFamily="34" charset="0"/>
+                <a:ea typeface="Inter" pitchFamily="34" charset="-122"/>
+                <a:cs typeface="Inter" pitchFamily="34" charset="-120"/>
+              </a:rPr>
+              <a:t>Jan–Sep, this year vs last</a:t>
+            </a:r>
+            <a:endParaRPr lang="en-US" sz="1200" dirty="0"/>
+          </a:p>
+        </p:txBody>
+      </p:sp>
+      <p:sp>
+        <p:nvSpPr>
+          <p:cNvPr id="24" name="Shape 22"/>
+          <p:cNvSpPr/>
+          <p:nvPr/>
+        </p:nvSpPr>
+        <p:spPr>
+          <a:xfrm>
+            <a:off x="4349496" y="2103120"/>
+            <a:ext cx="3489960" cy="1380744"/>
+          </a:xfrm>
+          <a:prstGeom prst="rect">
+            <a:avLst/>
+          </a:prstGeom>
+          <a:solidFill>
+            <a:srgbClr val="F7F7F7"/>
+          </a:solidFill>
+          <a:ln/>
+        </p:spPr>
+      </p:sp>
+      <p:sp>
+        <p:nvSpPr>
+          <p:cNvPr id="25" name="Text 23"/>
+          <p:cNvSpPr txBox="1"/>
+          <p:nvPr/>
+        </p:nvSpPr>
+        <p:spPr>
+          <a:xfrm>
+            <a:off x="4440936" y="2103120"/>
+            <a:ext cx="365760" cy="1380744"/>
+          </a:xfrm>
+          <a:prstGeom prst="rect">
+            <a:avLst/>
+          </a:prstGeom>
+          <a:noFill/>
+          <a:ln/>
+        </p:spPr>
+        <p:txBody>
+          <a:bodyPr wrap="square" lIns="0" tIns="0" rIns="0" bIns="0" rtlCol="0" anchor="ctr"/>
+          <a:lstStyle/>
+          <a:p>
+            <a:pPr indent="0" marL="0">
+              <a:buNone/>
+            </a:pPr>
+            <a:r>
+              <a:rPr lang="en-US" sz="2000" b="1" dirty="0">
                 <a:solidFill>
                   <a:srgbClr val="0B2C4A"/>
                 </a:solidFill>
@@ -18334,22 +18452,22 @@
                 <a:ea typeface="Inter" pitchFamily="34" charset="-122"/>
                 <a:cs typeface="Inter" pitchFamily="34" charset="-120"/>
               </a:rPr>
-              <a:t>4</a:t>
-            </a:r>
-            <a:endParaRPr lang="en-US" sz="1500" dirty="0"/>
-          </a:p>
-        </p:txBody>
-      </p:sp>
-      <p:sp>
-        <p:nvSpPr>
-          <p:cNvPr id="22" name="Text 20"/>
-          <p:cNvSpPr txBox="1"/>
-          <p:nvPr/>
-        </p:nvSpPr>
-        <p:spPr>
-          <a:xfrm>
-            <a:off x="1097280" y="4588459"/>
-            <a:ext cx="1825752" cy="828446"/>
+              <a:t>33</a:t>
+            </a:r>
+            <a:endParaRPr lang="en-US" sz="2000" dirty="0"/>
+          </a:p>
+        </p:txBody>
+      </p:sp>
+      <p:sp>
+        <p:nvSpPr>
+          <p:cNvPr id="26" name="Text 24"/>
+          <p:cNvSpPr txBox="1"/>
+          <p:nvPr/>
+        </p:nvSpPr>
+        <p:spPr>
+          <a:xfrm>
+            <a:off x="4852416" y="2103120"/>
+            <a:ext cx="1917192" cy="1380744"/>
           </a:xfrm>
           <a:prstGeom prst="rect">
             <a:avLst/>
@@ -18368,7 +18486,7 @@
               <a:buNone/>
             </a:pPr>
             <a:r>
-              <a:rPr lang="en-US" sz="1400" b="1" dirty="0">
+              <a:rPr lang="en-US" sz="1700" b="1" dirty="0">
                 <a:solidFill>
                   <a:srgbClr val="1A1A1A"/>
                 </a:solidFill>
@@ -18376,9 +18494,9 @@
                 <a:ea typeface="Inter" pitchFamily="34" charset="-122"/>
                 <a:cs typeface="Inter" pitchFamily="34" charset="-120"/>
               </a:rPr>
-              <a:t>Subaru St George</a:t>
-            </a:r>
-            <a:endParaRPr lang="en-US" sz="1400" dirty="0"/>
+              <a:t>LR Reno</a:t>
+            </a:r>
+            <a:endParaRPr lang="en-US" sz="1700" dirty="0"/>
           </a:p>
           <a:p>
             <a:pPr indent="0" marL="0">
@@ -18388,7 +18506,7 @@
               <a:buNone/>
             </a:pPr>
             <a:r>
-              <a:rPr lang="en-US" sz="1200" dirty="0">
+              <a:rPr lang="en-US" sz="1400" dirty="0">
                 <a:solidFill>
                   <a:srgbClr val="595959"/>
                 </a:solidFill>
@@ -18396,7 +18514,7 @@
                 <a:ea typeface="Inter" pitchFamily="34" charset="-122"/>
                 <a:cs typeface="Inter" pitchFamily="34" charset="-120"/>
               </a:rPr>
-              <a:t>49.8%  →  </a:t>
+              <a:t>69.6%  →  </a:t>
             </a:r>
             <a:pPr indent="0" marL="0">
               <a:spcAft>
@@ -18405,30 +18523,30 @@
               <a:buNone/>
             </a:pPr>
             <a:r>
-              <a:rPr lang="en-US" sz="1200" b="1" dirty="0">
-                <a:solidFill>
-                  <a:srgbClr val="0B7A4A"/>
-                </a:solidFill>
-                <a:latin typeface="Inter" pitchFamily="34" charset="0"/>
-                <a:ea typeface="Inter" pitchFamily="34" charset="-122"/>
-                <a:cs typeface="Inter" pitchFamily="34" charset="-120"/>
-              </a:rPr>
-              <a:t>59.0%</a:t>
-            </a:r>
-            <a:endParaRPr lang="en-US" sz="1400" dirty="0"/>
-          </a:p>
-        </p:txBody>
-      </p:sp>
-      <p:sp>
-        <p:nvSpPr>
-          <p:cNvPr id="23" name="Text 21"/>
-          <p:cNvSpPr txBox="1"/>
-          <p:nvPr/>
-        </p:nvSpPr>
-        <p:spPr>
-          <a:xfrm>
-            <a:off x="2941320" y="4588459"/>
-            <a:ext cx="1115568" cy="828446"/>
+              <a:rPr lang="en-US" sz="1400" b="1" dirty="0">
+                <a:solidFill>
+                  <a:srgbClr val="A82B26"/>
+                </a:solidFill>
+                <a:latin typeface="Inter" pitchFamily="34" charset="0"/>
+                <a:ea typeface="Inter" pitchFamily="34" charset="-122"/>
+                <a:cs typeface="Inter" pitchFamily="34" charset="-120"/>
+              </a:rPr>
+              <a:t>61.5%</a:t>
+            </a:r>
+            <a:endParaRPr lang="en-US" sz="1700" dirty="0"/>
+          </a:p>
+        </p:txBody>
+      </p:sp>
+      <p:sp>
+        <p:nvSpPr>
+          <p:cNvPr id="27" name="Text 25"/>
+          <p:cNvSpPr txBox="1"/>
+          <p:nvPr/>
+        </p:nvSpPr>
+        <p:spPr>
+          <a:xfrm>
+            <a:off x="6815328" y="2103120"/>
+            <a:ext cx="932688" cy="1380744"/>
           </a:xfrm>
           <a:prstGeom prst="rect">
             <a:avLst/>
@@ -18444,50 +18562,30 @@
               <a:buNone/>
             </a:pPr>
             <a:r>
-              <a:rPr lang="en-US" sz="1600" b="1" dirty="0">
-                <a:solidFill>
-                  <a:srgbClr val="0B7A4A"/>
-                </a:solidFill>
-                <a:latin typeface="Inter" pitchFamily="34" charset="0"/>
-                <a:ea typeface="Inter" pitchFamily="34" charset="-122"/>
-                <a:cs typeface="Inter" pitchFamily="34" charset="-120"/>
-              </a:rPr>
-              <a:t>+9.2 pts</a:t>
-            </a:r>
-            <a:endParaRPr lang="en-US" sz="1600" dirty="0"/>
-          </a:p>
-        </p:txBody>
-      </p:sp>
-      <p:sp>
-        <p:nvSpPr>
-          <p:cNvPr id="24" name="Shape 22"/>
-          <p:cNvSpPr/>
-          <p:nvPr/>
-        </p:nvSpPr>
-        <p:spPr>
-          <a:xfrm>
-            <a:off x="658368" y="5416906"/>
-            <a:ext cx="3489960" cy="828446"/>
-          </a:xfrm>
-          <a:prstGeom prst="rect">
-            <a:avLst/>
-          </a:prstGeom>
-          <a:solidFill>
-            <a:srgbClr val="F7F7F7"/>
-          </a:solidFill>
-          <a:ln/>
-        </p:spPr>
-      </p:sp>
-      <p:sp>
-        <p:nvSpPr>
-          <p:cNvPr id="25" name="Text 23"/>
-          <p:cNvSpPr txBox="1"/>
-          <p:nvPr/>
-        </p:nvSpPr>
-        <p:spPr>
-          <a:xfrm>
-            <a:off x="749808" y="5416906"/>
-            <a:ext cx="365760" cy="828446"/>
+              <a:rPr lang="en-US" sz="1800" b="1" dirty="0">
+                <a:solidFill>
+                  <a:srgbClr val="A82B26"/>
+                </a:solidFill>
+                <a:latin typeface="Inter" pitchFamily="34" charset="0"/>
+                <a:ea typeface="Inter" pitchFamily="34" charset="-122"/>
+                <a:cs typeface="Inter" pitchFamily="34" charset="-120"/>
+              </a:rPr>
+              <a:t>−8.1 pts</a:t>
+            </a:r>
+            <a:endParaRPr lang="en-US" sz="1800" dirty="0"/>
+          </a:p>
+        </p:txBody>
+      </p:sp>
+      <p:sp>
+        <p:nvSpPr>
+          <p:cNvPr id="28" name="Text 26"/>
+          <p:cNvSpPr txBox="1"/>
+          <p:nvPr/>
+        </p:nvSpPr>
+        <p:spPr>
+          <a:xfrm>
+            <a:off x="4440936" y="3483864"/>
+            <a:ext cx="365760" cy="1380744"/>
           </a:xfrm>
           <a:prstGeom prst="rect">
             <a:avLst/>
@@ -18503,7 +18601,7 @@
               <a:buNone/>
             </a:pPr>
             <a:r>
-              <a:rPr lang="en-US" sz="1500" b="1" dirty="0">
+              <a:rPr lang="en-US" sz="2000" b="1" dirty="0">
                 <a:solidFill>
                   <a:srgbClr val="0B2C4A"/>
                 </a:solidFill>
@@ -18511,22 +18609,22 @@
                 <a:ea typeface="Inter" pitchFamily="34" charset="-122"/>
                 <a:cs typeface="Inter" pitchFamily="34" charset="-120"/>
               </a:rPr>
-              <a:t>5</a:t>
-            </a:r>
-            <a:endParaRPr lang="en-US" sz="1500" dirty="0"/>
-          </a:p>
-        </p:txBody>
-      </p:sp>
-      <p:sp>
-        <p:nvSpPr>
-          <p:cNvPr id="26" name="Text 24"/>
-          <p:cNvSpPr txBox="1"/>
-          <p:nvPr/>
-        </p:nvSpPr>
-        <p:spPr>
-          <a:xfrm>
-            <a:off x="1097280" y="5416906"/>
-            <a:ext cx="1825752" cy="828446"/>
+              <a:t>32</a:t>
+            </a:r>
+            <a:endParaRPr lang="en-US" sz="2000" dirty="0"/>
+          </a:p>
+        </p:txBody>
+      </p:sp>
+      <p:sp>
+        <p:nvSpPr>
+          <p:cNvPr id="29" name="Text 27"/>
+          <p:cNvSpPr txBox="1"/>
+          <p:nvPr/>
+        </p:nvSpPr>
+        <p:spPr>
+          <a:xfrm>
+            <a:off x="4852416" y="3483864"/>
+            <a:ext cx="1917192" cy="1380744"/>
           </a:xfrm>
           <a:prstGeom prst="rect">
             <a:avLst/>
@@ -18545,7 +18643,7 @@
               <a:buNone/>
             </a:pPr>
             <a:r>
-              <a:rPr lang="en-US" sz="1400" b="1" dirty="0">
+              <a:rPr lang="en-US" sz="1700" b="1" dirty="0">
                 <a:solidFill>
                   <a:srgbClr val="1A1A1A"/>
                 </a:solidFill>
@@ -18553,9 +18651,9 @@
                 <a:ea typeface="Inter" pitchFamily="34" charset="-122"/>
                 <a:cs typeface="Inter" pitchFamily="34" charset="-120"/>
               </a:rPr>
-              <a:t>Subaru Prescott</a:t>
-            </a:r>
-            <a:endParaRPr lang="en-US" sz="1400" dirty="0"/>
+              <a:t>Hyundai Prescott</a:t>
+            </a:r>
+            <a:endParaRPr lang="en-US" sz="1700" dirty="0"/>
           </a:p>
           <a:p>
             <a:pPr indent="0" marL="0">
@@ -18565,7 +18663,7 @@
               <a:buNone/>
             </a:pPr>
             <a:r>
-              <a:rPr lang="en-US" sz="1200" dirty="0">
+              <a:rPr lang="en-US" sz="1400" dirty="0">
                 <a:solidFill>
                   <a:srgbClr val="595959"/>
                 </a:solidFill>
@@ -18573,7 +18671,7 @@
                 <a:ea typeface="Inter" pitchFamily="34" charset="-122"/>
                 <a:cs typeface="Inter" pitchFamily="34" charset="-120"/>
               </a:rPr>
-              <a:t>41.8%  →  </a:t>
+              <a:t>35.3%  →  </a:t>
             </a:r>
             <a:pPr indent="0" marL="0">
               <a:spcAft>
@@ -18582,30 +18680,30 @@
               <a:buNone/>
             </a:pPr>
             <a:r>
-              <a:rPr lang="en-US" sz="1200" b="1" dirty="0">
-                <a:solidFill>
-                  <a:srgbClr val="0B7A4A"/>
-                </a:solidFill>
-                <a:latin typeface="Inter" pitchFamily="34" charset="0"/>
-                <a:ea typeface="Inter" pitchFamily="34" charset="-122"/>
-                <a:cs typeface="Inter" pitchFamily="34" charset="-120"/>
-              </a:rPr>
-              <a:t>50.8%</a:t>
-            </a:r>
-            <a:endParaRPr lang="en-US" sz="1400" dirty="0"/>
-          </a:p>
-        </p:txBody>
-      </p:sp>
-      <p:sp>
-        <p:nvSpPr>
-          <p:cNvPr id="27" name="Text 25"/>
-          <p:cNvSpPr txBox="1"/>
-          <p:nvPr/>
-        </p:nvSpPr>
-        <p:spPr>
-          <a:xfrm>
-            <a:off x="2941320" y="5416906"/>
-            <a:ext cx="1115568" cy="828446"/>
+              <a:rPr lang="en-US" sz="1400" b="1" dirty="0">
+                <a:solidFill>
+                  <a:srgbClr val="A82B26"/>
+                </a:solidFill>
+                <a:latin typeface="Inter" pitchFamily="34" charset="0"/>
+                <a:ea typeface="Inter" pitchFamily="34" charset="-122"/>
+                <a:cs typeface="Inter" pitchFamily="34" charset="-120"/>
+              </a:rPr>
+              <a:t>28.5%</a:t>
+            </a:r>
+            <a:endParaRPr lang="en-US" sz="1700" dirty="0"/>
+          </a:p>
+        </p:txBody>
+      </p:sp>
+      <p:sp>
+        <p:nvSpPr>
+          <p:cNvPr id="30" name="Text 28"/>
+          <p:cNvSpPr txBox="1"/>
+          <p:nvPr/>
+        </p:nvSpPr>
+        <p:spPr>
+          <a:xfrm>
+            <a:off x="6815328" y="3483864"/>
+            <a:ext cx="932688" cy="1380744"/>
           </a:xfrm>
           <a:prstGeom prst="rect">
             <a:avLst/>
@@ -18621,66 +18719,7 @@
               <a:buNone/>
             </a:pPr>
             <a:r>
-              <a:rPr lang="en-US" sz="1600" b="1" dirty="0">
-                <a:solidFill>
-                  <a:srgbClr val="0B7A4A"/>
-                </a:solidFill>
-                <a:latin typeface="Inter" pitchFamily="34" charset="0"/>
-                <a:ea typeface="Inter" pitchFamily="34" charset="-122"/>
-                <a:cs typeface="Inter" pitchFamily="34" charset="-120"/>
-              </a:rPr>
-              <a:t>+9.0 pts</a:t>
-            </a:r>
-            <a:endParaRPr lang="en-US" sz="1600" dirty="0"/>
-          </a:p>
-        </p:txBody>
-      </p:sp>
-      <p:sp>
-        <p:nvSpPr>
-          <p:cNvPr id="28" name="Shape 26"/>
-          <p:cNvSpPr/>
-          <p:nvPr/>
-        </p:nvSpPr>
-        <p:spPr>
-          <a:xfrm>
-            <a:off x="4349496" y="1371600"/>
-            <a:ext cx="3489960" cy="45720"/>
-          </a:xfrm>
-          <a:prstGeom prst="rect">
-            <a:avLst/>
-          </a:prstGeom>
-          <a:solidFill>
-            <a:srgbClr val="C2352F"/>
-          </a:solidFill>
-          <a:ln/>
-        </p:spPr>
-      </p:sp>
-      <p:sp>
-        <p:nvSpPr>
-          <p:cNvPr id="29" name="Text 27"/>
-          <p:cNvSpPr txBox="1"/>
-          <p:nvPr/>
-        </p:nvSpPr>
-        <p:spPr>
-          <a:xfrm>
-            <a:off x="4440936" y="1444752"/>
-            <a:ext cx="3307080" cy="274320"/>
-          </a:xfrm>
-          <a:prstGeom prst="rect">
-            <a:avLst/>
-          </a:prstGeom>
-          <a:noFill/>
-          <a:ln/>
-        </p:spPr>
-        <p:txBody>
-          <a:bodyPr wrap="square" lIns="0" tIns="0" rIns="0" bIns="0" rtlCol="0" anchor="ctr"/>
-          <a:lstStyle/>
-          <a:p>
-            <a:pPr indent="0" marL="0">
-              <a:buNone/>
-            </a:pPr>
-            <a:r>
-              <a:rPr lang="en-US" sz="1500" b="1" spc="100" kern="0" dirty="0">
+              <a:rPr lang="en-US" sz="1800" b="1" dirty="0">
                 <a:solidFill>
                   <a:srgbClr val="A82B26"/>
                 </a:solidFill>
@@ -18688,48 +18727,9 @@
                 <a:ea typeface="Inter" pitchFamily="34" charset="-122"/>
                 <a:cs typeface="Inter" pitchFamily="34" charset="-120"/>
               </a:rPr>
-              <a:t>BOTTOM 5 VS LAST YEAR</a:t>
-            </a:r>
-            <a:endParaRPr lang="en-US" sz="1500" dirty="0"/>
-          </a:p>
-        </p:txBody>
-      </p:sp>
-      <p:sp>
-        <p:nvSpPr>
-          <p:cNvPr id="30" name="Text 28"/>
-          <p:cNvSpPr txBox="1"/>
-          <p:nvPr/>
-        </p:nvSpPr>
-        <p:spPr>
-          <a:xfrm>
-            <a:off x="4440936" y="1737360"/>
-            <a:ext cx="3307080" cy="274320"/>
-          </a:xfrm>
-          <a:prstGeom prst="rect">
-            <a:avLst/>
-          </a:prstGeom>
-          <a:noFill/>
-          <a:ln/>
-        </p:spPr>
-        <p:txBody>
-          <a:bodyPr wrap="square" lIns="0" tIns="0" rIns="0" bIns="0" rtlCol="0" anchor="ctr"/>
-          <a:lstStyle/>
-          <a:p>
-            <a:pPr indent="0" marL="0">
-              <a:buNone/>
-            </a:pPr>
-            <a:r>
-              <a:rPr lang="en-US" sz="1200" dirty="0">
-                <a:solidFill>
-                  <a:srgbClr val="595959"/>
-                </a:solidFill>
-                <a:latin typeface="Inter" pitchFamily="34" charset="0"/>
-                <a:ea typeface="Inter" pitchFamily="34" charset="-122"/>
-                <a:cs typeface="Inter" pitchFamily="34" charset="-120"/>
-              </a:rPr>
-              <a:t>Jan–Sep, this year vs last</a:t>
-            </a:r>
-            <a:endParaRPr lang="en-US" sz="1200" dirty="0"/>
+              <a:t>−6.8 pts</a:t>
+            </a:r>
+            <a:endParaRPr lang="en-US" sz="1800" dirty="0"/>
           </a:p>
         </p:txBody>
       </p:sp>
@@ -18741,8 +18741,8 @@
         </p:nvSpPr>
         <p:spPr>
           <a:xfrm>
-            <a:off x="4349496" y="2103120"/>
-            <a:ext cx="3489960" cy="828446"/>
+            <a:off x="4349496" y="4864608"/>
+            <a:ext cx="3489960" cy="1380744"/>
           </a:xfrm>
           <a:prstGeom prst="rect">
             <a:avLst/>
@@ -18761,8 +18761,8 @@
         </p:nvSpPr>
         <p:spPr>
           <a:xfrm>
-            <a:off x="4440936" y="2103120"/>
-            <a:ext cx="365760" cy="828446"/>
+            <a:off x="4440936" y="4864608"/>
+            <a:ext cx="365760" cy="1380744"/>
           </a:xfrm>
           <a:prstGeom prst="rect">
             <a:avLst/>
@@ -18778,7 +18778,7 @@
               <a:buNone/>
             </a:pPr>
             <a:r>
-              <a:rPr lang="en-US" sz="1500" b="1" dirty="0">
+              <a:rPr lang="en-US" sz="2000" b="1" dirty="0">
                 <a:solidFill>
                   <a:srgbClr val="0B2C4A"/>
                 </a:solidFill>
@@ -18786,9 +18786,9 @@
                 <a:ea typeface="Inter" pitchFamily="34" charset="-122"/>
                 <a:cs typeface="Inter" pitchFamily="34" charset="-120"/>
               </a:rPr>
-              <a:t>33</a:t>
-            </a:r>
-            <a:endParaRPr lang="en-US" sz="1500" dirty="0"/>
+              <a:t>31</a:t>
+            </a:r>
+            <a:endParaRPr lang="en-US" sz="2000" dirty="0"/>
           </a:p>
         </p:txBody>
       </p:sp>
@@ -18800,8 +18800,8 @@
         </p:nvSpPr>
         <p:spPr>
           <a:xfrm>
-            <a:off x="4788408" y="2103120"/>
-            <a:ext cx="1825752" cy="828446"/>
+            <a:off x="4852416" y="4864608"/>
+            <a:ext cx="1917192" cy="1380744"/>
           </a:xfrm>
           <a:prstGeom prst="rect">
             <a:avLst/>
@@ -18820,7 +18820,7 @@
               <a:buNone/>
             </a:pPr>
             <a:r>
-              <a:rPr lang="en-US" sz="1400" b="1" dirty="0">
+              <a:rPr lang="en-US" sz="1700" b="1" dirty="0">
                 <a:solidFill>
                   <a:srgbClr val="1A1A1A"/>
                 </a:solidFill>
@@ -18828,9 +18828,9 @@
                 <a:ea typeface="Inter" pitchFamily="34" charset="-122"/>
                 <a:cs typeface="Inter" pitchFamily="34" charset="-120"/>
               </a:rPr>
-              <a:t>LR Reno</a:t>
-            </a:r>
-            <a:endParaRPr lang="en-US" sz="1400" dirty="0"/>
+              <a:t>Toyota Henderson</a:t>
+            </a:r>
+            <a:endParaRPr lang="en-US" sz="1700" dirty="0"/>
           </a:p>
           <a:p>
             <a:pPr indent="0" marL="0">
@@ -18840,7 +18840,7 @@
               <a:buNone/>
             </a:pPr>
             <a:r>
-              <a:rPr lang="en-US" sz="1200" dirty="0">
+              <a:rPr lang="en-US" sz="1400" dirty="0">
                 <a:solidFill>
                   <a:srgbClr val="595959"/>
                 </a:solidFill>
@@ -18848,7 +18848,7 @@
                 <a:ea typeface="Inter" pitchFamily="34" charset="-122"/>
                 <a:cs typeface="Inter" pitchFamily="34" charset="-120"/>
               </a:rPr>
-              <a:t>69.6%  →  </a:t>
+              <a:t>63.8%  →  </a:t>
             </a:r>
             <a:pPr indent="0" marL="0">
               <a:spcAft>
@@ -18857,7 +18857,7 @@
               <a:buNone/>
             </a:pPr>
             <a:r>
-              <a:rPr lang="en-US" sz="1200" b="1" dirty="0">
+              <a:rPr lang="en-US" sz="1400" b="1" dirty="0">
                 <a:solidFill>
                   <a:srgbClr val="A82B26"/>
                 </a:solidFill>
@@ -18865,9 +18865,9 @@
                 <a:ea typeface="Inter" pitchFamily="34" charset="-122"/>
                 <a:cs typeface="Inter" pitchFamily="34" charset="-120"/>
               </a:rPr>
-              <a:t>61.5%</a:t>
-            </a:r>
-            <a:endParaRPr lang="en-US" sz="1400" dirty="0"/>
+              <a:t>57.3%</a:t>
+            </a:r>
+            <a:endParaRPr lang="en-US" sz="1700" dirty="0"/>
           </a:p>
         </p:txBody>
       </p:sp>
@@ -18879,8 +18879,8 @@
         </p:nvSpPr>
         <p:spPr>
           <a:xfrm>
-            <a:off x="6632448" y="2103120"/>
-            <a:ext cx="1115568" cy="828446"/>
+            <a:off x="6815328" y="4864608"/>
+            <a:ext cx="932688" cy="1380744"/>
           </a:xfrm>
           <a:prstGeom prst="rect">
             <a:avLst/>
@@ -18896,7 +18896,7 @@
               <a:buNone/>
             </a:pPr>
             <a:r>
-              <a:rPr lang="en-US" sz="1600" b="1" dirty="0">
+              <a:rPr lang="en-US" sz="1800" b="1" dirty="0">
                 <a:solidFill>
                   <a:srgbClr val="A82B26"/>
                 </a:solidFill>
@@ -18904,22 +18904,42 @@
                 <a:ea typeface="Inter" pitchFamily="34" charset="-122"/>
                 <a:cs typeface="Inter" pitchFamily="34" charset="-120"/>
               </a:rPr>
-              <a:t>−8.1 pts</a:t>
-            </a:r>
-            <a:endParaRPr lang="en-US" sz="1600" dirty="0"/>
-          </a:p>
-        </p:txBody>
-      </p:sp>
-      <p:sp>
-        <p:nvSpPr>
-          <p:cNvPr id="35" name="Text 33"/>
-          <p:cNvSpPr txBox="1"/>
-          <p:nvPr/>
-        </p:nvSpPr>
-        <p:spPr>
-          <a:xfrm>
-            <a:off x="4440936" y="2931566"/>
-            <a:ext cx="365760" cy="828446"/>
+              <a:t>−6.5 pts</a:t>
+            </a:r>
+            <a:endParaRPr lang="en-US" sz="1800" dirty="0"/>
+          </a:p>
+        </p:txBody>
+      </p:sp>
+      <p:sp>
+        <p:nvSpPr>
+          <p:cNvPr id="35" name="Shape 33"/>
+          <p:cNvSpPr/>
+          <p:nvPr/>
+        </p:nvSpPr>
+        <p:spPr>
+          <a:xfrm>
+            <a:off x="8040624" y="1371600"/>
+            <a:ext cx="3489960" cy="45720"/>
+          </a:xfrm>
+          <a:prstGeom prst="rect">
+            <a:avLst/>
+          </a:prstGeom>
+          <a:solidFill>
+            <a:srgbClr val="2587C5"/>
+          </a:solidFill>
+          <a:ln/>
+        </p:spPr>
+      </p:sp>
+      <p:sp>
+        <p:nvSpPr>
+          <p:cNvPr id="36" name="Text 34"/>
+          <p:cNvSpPr txBox="1"/>
+          <p:nvPr/>
+        </p:nvSpPr>
+        <p:spPr>
+          <a:xfrm>
+            <a:off x="8132064" y="1444752"/>
+            <a:ext cx="3307080" cy="274320"/>
           </a:xfrm>
           <a:prstGeom prst="rect">
             <a:avLst/>
@@ -18935,7 +18955,7 @@
               <a:buNone/>
             </a:pPr>
             <a:r>
-              <a:rPr lang="en-US" sz="1500" b="1" dirty="0">
+              <a:rPr lang="en-US" sz="1500" b="1" spc="100" kern="0" dirty="0">
                 <a:solidFill>
                   <a:srgbClr val="0B2C4A"/>
                 </a:solidFill>
@@ -18943,7 +18963,7 @@
                 <a:ea typeface="Inter" pitchFamily="34" charset="-122"/>
                 <a:cs typeface="Inter" pitchFamily="34" charset="-120"/>
               </a:rPr>
-              <a:t>32</a:t>
+              <a:t>TOP 3 MOVING NOW</a:t>
             </a:r>
             <a:endParaRPr lang="en-US" sz="1500" dirty="0"/>
           </a:p>
@@ -18951,14 +18971,112 @@
       </p:sp>
       <p:sp>
         <p:nvSpPr>
-          <p:cNvPr id="36" name="Text 34"/>
-          <p:cNvSpPr txBox="1"/>
-          <p:nvPr/>
-        </p:nvSpPr>
-        <p:spPr>
-          <a:xfrm>
-            <a:off x="4788408" y="2931566"/>
-            <a:ext cx="1825752" cy="828446"/>
+          <p:cNvPr id="37" name="Text 35"/>
+          <p:cNvSpPr txBox="1"/>
+          <p:nvPr/>
+        </p:nvSpPr>
+        <p:spPr>
+          <a:xfrm>
+            <a:off x="8132064" y="1737360"/>
+            <a:ext cx="3307080" cy="274320"/>
+          </a:xfrm>
+          <a:prstGeom prst="rect">
+            <a:avLst/>
+          </a:prstGeom>
+          <a:noFill/>
+          <a:ln/>
+        </p:spPr>
+        <p:txBody>
+          <a:bodyPr wrap="square" lIns="0" tIns="0" rIns="0" bIns="0" rtlCol="0" anchor="ctr"/>
+          <a:lstStyle/>
+          <a:p>
+            <a:pPr indent="0" marL="0">
+              <a:buNone/>
+            </a:pPr>
+            <a:r>
+              <a:rPr lang="en-US" sz="1200" dirty="0">
+                <a:solidFill>
+                  <a:srgbClr val="595959"/>
+                </a:solidFill>
+                <a:latin typeface="Inter" pitchFamily="34" charset="0"/>
+                <a:ea typeface="Inter" pitchFamily="34" charset="-122"/>
+                <a:cs typeface="Inter" pitchFamily="34" charset="-120"/>
+              </a:rPr>
+              <a:t>Q3 vs Q1, this year</a:t>
+            </a:r>
+            <a:endParaRPr lang="en-US" sz="1200" dirty="0"/>
+          </a:p>
+        </p:txBody>
+      </p:sp>
+      <p:sp>
+        <p:nvSpPr>
+          <p:cNvPr id="38" name="Shape 36"/>
+          <p:cNvSpPr/>
+          <p:nvPr/>
+        </p:nvSpPr>
+        <p:spPr>
+          <a:xfrm>
+            <a:off x="8040624" y="2103120"/>
+            <a:ext cx="3489960" cy="1380744"/>
+          </a:xfrm>
+          <a:prstGeom prst="rect">
+            <a:avLst/>
+          </a:prstGeom>
+          <a:solidFill>
+            <a:srgbClr val="F7F7F7"/>
+          </a:solidFill>
+          <a:ln/>
+        </p:spPr>
+      </p:sp>
+      <p:sp>
+        <p:nvSpPr>
+          <p:cNvPr id="39" name="Text 37"/>
+          <p:cNvSpPr txBox="1"/>
+          <p:nvPr/>
+        </p:nvSpPr>
+        <p:spPr>
+          <a:xfrm>
+            <a:off x="8132064" y="2103120"/>
+            <a:ext cx="365760" cy="1380744"/>
+          </a:xfrm>
+          <a:prstGeom prst="rect">
+            <a:avLst/>
+          </a:prstGeom>
+          <a:noFill/>
+          <a:ln/>
+        </p:spPr>
+        <p:txBody>
+          <a:bodyPr wrap="square" lIns="0" tIns="0" rIns="0" bIns="0" rtlCol="0" anchor="ctr"/>
+          <a:lstStyle/>
+          <a:p>
+            <a:pPr indent="0" marL="0">
+              <a:buNone/>
+            </a:pPr>
+            <a:r>
+              <a:rPr lang="en-US" sz="2000" b="1" dirty="0">
+                <a:solidFill>
+                  <a:srgbClr val="0B2C4A"/>
+                </a:solidFill>
+                <a:latin typeface="Inter" pitchFamily="34" charset="0"/>
+                <a:ea typeface="Inter" pitchFamily="34" charset="-122"/>
+                <a:cs typeface="Inter" pitchFamily="34" charset="-120"/>
+              </a:rPr>
+              <a:t>1</a:t>
+            </a:r>
+            <a:endParaRPr lang="en-US" sz="2000" dirty="0"/>
+          </a:p>
+        </p:txBody>
+      </p:sp>
+      <p:sp>
+        <p:nvSpPr>
+          <p:cNvPr id="40" name="Text 38"/>
+          <p:cNvSpPr txBox="1"/>
+          <p:nvPr/>
+        </p:nvSpPr>
+        <p:spPr>
+          <a:xfrm>
+            <a:off x="8543544" y="2103120"/>
+            <a:ext cx="1917192" cy="1380744"/>
           </a:xfrm>
           <a:prstGeom prst="rect">
             <a:avLst/>
@@ -18977,7 +19095,7 @@
               <a:buNone/>
             </a:pPr>
             <a:r>
-              <a:rPr lang="en-US" sz="1400" b="1" dirty="0">
+              <a:rPr lang="en-US" sz="1700" b="1" dirty="0">
                 <a:solidFill>
                   <a:srgbClr val="1A1A1A"/>
                 </a:solidFill>
@@ -18985,9 +19103,9 @@
                 <a:ea typeface="Inter" pitchFamily="34" charset="-122"/>
                 <a:cs typeface="Inter" pitchFamily="34" charset="-120"/>
               </a:rPr>
-              <a:t>Hyundai Prescott</a:t>
-            </a:r>
-            <a:endParaRPr lang="en-US" sz="1400" dirty="0"/>
+              <a:t>Lexus</a:t>
+            </a:r>
+            <a:endParaRPr lang="en-US" sz="1700" dirty="0"/>
           </a:p>
           <a:p>
             <a:pPr indent="0" marL="0">
@@ -18997,7 +19115,7 @@
               <a:buNone/>
             </a:pPr>
             <a:r>
-              <a:rPr lang="en-US" sz="1200" dirty="0">
+              <a:rPr lang="en-US" sz="1400" dirty="0">
                 <a:solidFill>
                   <a:srgbClr val="595959"/>
                 </a:solidFill>
@@ -19005,7 +19123,7 @@
                 <a:ea typeface="Inter" pitchFamily="34" charset="-122"/>
                 <a:cs typeface="Inter" pitchFamily="34" charset="-120"/>
               </a:rPr>
-              <a:t>35.3%  →  </a:t>
+              <a:t>48.9%  →  </a:t>
             </a:r>
             <a:pPr indent="0" marL="0">
               <a:spcAft>
@@ -19014,30 +19132,30 @@
               <a:buNone/>
             </a:pPr>
             <a:r>
-              <a:rPr lang="en-US" sz="1200" b="1" dirty="0">
-                <a:solidFill>
-                  <a:srgbClr val="A82B26"/>
-                </a:solidFill>
-                <a:latin typeface="Inter" pitchFamily="34" charset="0"/>
-                <a:ea typeface="Inter" pitchFamily="34" charset="-122"/>
-                <a:cs typeface="Inter" pitchFamily="34" charset="-120"/>
-              </a:rPr>
-              <a:t>28.5%</a:t>
-            </a:r>
-            <a:endParaRPr lang="en-US" sz="1400" dirty="0"/>
-          </a:p>
-        </p:txBody>
-      </p:sp>
-      <p:sp>
-        <p:nvSpPr>
-          <p:cNvPr id="37" name="Text 35"/>
-          <p:cNvSpPr txBox="1"/>
-          <p:nvPr/>
-        </p:nvSpPr>
-        <p:spPr>
-          <a:xfrm>
-            <a:off x="6632448" y="2931566"/>
-            <a:ext cx="1115568" cy="828446"/>
+              <a:rPr lang="en-US" sz="1400" b="1" dirty="0">
+                <a:solidFill>
+                  <a:srgbClr val="0B7A4A"/>
+                </a:solidFill>
+                <a:latin typeface="Inter" pitchFamily="34" charset="0"/>
+                <a:ea typeface="Inter" pitchFamily="34" charset="-122"/>
+                <a:cs typeface="Inter" pitchFamily="34" charset="-120"/>
+              </a:rPr>
+              <a:t>57.7%</a:t>
+            </a:r>
+            <a:endParaRPr lang="en-US" sz="1700" dirty="0"/>
+          </a:p>
+        </p:txBody>
+      </p:sp>
+      <p:sp>
+        <p:nvSpPr>
+          <p:cNvPr id="41" name="Text 39"/>
+          <p:cNvSpPr txBox="1"/>
+          <p:nvPr/>
+        </p:nvSpPr>
+        <p:spPr>
+          <a:xfrm>
+            <a:off x="10506456" y="2103120"/>
+            <a:ext cx="932688" cy="1380744"/>
           </a:xfrm>
           <a:prstGeom prst="rect">
             <a:avLst/>
@@ -19053,50 +19171,50 @@
               <a:buNone/>
             </a:pPr>
             <a:r>
-              <a:rPr lang="en-US" sz="1600" b="1" dirty="0">
-                <a:solidFill>
-                  <a:srgbClr val="A82B26"/>
-                </a:solidFill>
-                <a:latin typeface="Inter" pitchFamily="34" charset="0"/>
-                <a:ea typeface="Inter" pitchFamily="34" charset="-122"/>
-                <a:cs typeface="Inter" pitchFamily="34" charset="-120"/>
-              </a:rPr>
-              <a:t>−6.8 pts</a:t>
-            </a:r>
-            <a:endParaRPr lang="en-US" sz="1600" dirty="0"/>
-          </a:p>
-        </p:txBody>
-      </p:sp>
-      <p:sp>
-        <p:nvSpPr>
-          <p:cNvPr id="38" name="Shape 36"/>
+              <a:rPr lang="en-US" sz="1800" b="1" dirty="0">
+                <a:solidFill>
+                  <a:srgbClr val="0B7A4A"/>
+                </a:solidFill>
+                <a:latin typeface="Inter" pitchFamily="34" charset="0"/>
+                <a:ea typeface="Inter" pitchFamily="34" charset="-122"/>
+                <a:cs typeface="Inter" pitchFamily="34" charset="-120"/>
+              </a:rPr>
+              <a:t>+8.8 pts</a:t>
+            </a:r>
+            <a:endParaRPr lang="en-US" sz="1800" dirty="0"/>
+          </a:p>
+        </p:txBody>
+      </p:sp>
+      <p:sp>
+        <p:nvSpPr>
+          <p:cNvPr id="42" name="Shape 40"/>
           <p:cNvSpPr/>
           <p:nvPr/>
         </p:nvSpPr>
         <p:spPr>
           <a:xfrm>
-            <a:off x="4349496" y="3760013"/>
-            <a:ext cx="3489960" cy="828446"/>
-          </a:xfrm>
-          <a:prstGeom prst="rect">
-            <a:avLst/>
-          </a:prstGeom>
-          <a:solidFill>
-            <a:srgbClr val="F7F7F7"/>
-          </a:solidFill>
-          <a:ln/>
-        </p:spPr>
-      </p:sp>
-      <p:sp>
-        <p:nvSpPr>
-          <p:cNvPr id="39" name="Text 37"/>
-          <p:cNvSpPr txBox="1"/>
-          <p:nvPr/>
-        </p:nvSpPr>
-        <p:spPr>
-          <a:xfrm>
-            <a:off x="4440936" y="3760013"/>
-            <a:ext cx="365760" cy="828446"/>
+            <a:off x="11466576" y="3520440"/>
+            <a:ext cx="64008" cy="1307592"/>
+          </a:xfrm>
+          <a:prstGeom prst="rect">
+            <a:avLst/>
+          </a:prstGeom>
+          <a:solidFill>
+            <a:srgbClr val="12A566"/>
+          </a:solidFill>
+          <a:ln/>
+        </p:spPr>
+      </p:sp>
+      <p:sp>
+        <p:nvSpPr>
+          <p:cNvPr id="43" name="Text 41"/>
+          <p:cNvSpPr txBox="1"/>
+          <p:nvPr/>
+        </p:nvSpPr>
+        <p:spPr>
+          <a:xfrm>
+            <a:off x="8132064" y="3483864"/>
+            <a:ext cx="365760" cy="1380744"/>
           </a:xfrm>
           <a:prstGeom prst="rect">
             <a:avLst/>
@@ -19112,7 +19230,7 @@
               <a:buNone/>
             </a:pPr>
             <a:r>
-              <a:rPr lang="en-US" sz="1500" b="1" dirty="0">
+              <a:rPr lang="en-US" sz="2000" b="1" dirty="0">
                 <a:solidFill>
                   <a:srgbClr val="0B2C4A"/>
                 </a:solidFill>
@@ -19120,22 +19238,22 @@
                 <a:ea typeface="Inter" pitchFamily="34" charset="-122"/>
                 <a:cs typeface="Inter" pitchFamily="34" charset="-120"/>
               </a:rPr>
-              <a:t>31</a:t>
-            </a:r>
-            <a:endParaRPr lang="en-US" sz="1500" dirty="0"/>
-          </a:p>
-        </p:txBody>
-      </p:sp>
-      <p:sp>
-        <p:nvSpPr>
-          <p:cNvPr id="40" name="Text 38"/>
-          <p:cNvSpPr txBox="1"/>
-          <p:nvPr/>
-        </p:nvSpPr>
-        <p:spPr>
-          <a:xfrm>
-            <a:off x="4788408" y="3760013"/>
-            <a:ext cx="1825752" cy="828446"/>
+              <a:t>2</a:t>
+            </a:r>
+            <a:endParaRPr lang="en-US" sz="2000" dirty="0"/>
+          </a:p>
+        </p:txBody>
+      </p:sp>
+      <p:sp>
+        <p:nvSpPr>
+          <p:cNvPr id="44" name="Text 42"/>
+          <p:cNvSpPr txBox="1"/>
+          <p:nvPr/>
+        </p:nvSpPr>
+        <p:spPr>
+          <a:xfrm>
+            <a:off x="8543544" y="3483864"/>
+            <a:ext cx="1917192" cy="1380744"/>
           </a:xfrm>
           <a:prstGeom prst="rect">
             <a:avLst/>
@@ -19154,7 +19272,7 @@
               <a:buNone/>
             </a:pPr>
             <a:r>
-              <a:rPr lang="en-US" sz="1400" b="1" dirty="0">
+              <a:rPr lang="en-US" sz="1700" b="1" dirty="0">
                 <a:solidFill>
                   <a:srgbClr val="1A1A1A"/>
                 </a:solidFill>
@@ -19162,9 +19280,9 @@
                 <a:ea typeface="Inter" pitchFamily="34" charset="-122"/>
                 <a:cs typeface="Inter" pitchFamily="34" charset="-120"/>
               </a:rPr>
-              <a:t>Toyota Henderson</a:t>
-            </a:r>
-            <a:endParaRPr lang="en-US" sz="1400" dirty="0"/>
+              <a:t>Acura</a:t>
+            </a:r>
+            <a:endParaRPr lang="en-US" sz="1700" dirty="0"/>
           </a:p>
           <a:p>
             <a:pPr indent="0" marL="0">
@@ -19174,7 +19292,7 @@
               <a:buNone/>
             </a:pPr>
             <a:r>
-              <a:rPr lang="en-US" sz="1200" dirty="0">
+              <a:rPr lang="en-US" sz="1400" dirty="0">
                 <a:solidFill>
                   <a:srgbClr val="595959"/>
                 </a:solidFill>
@@ -19182,7 +19300,7 @@
                 <a:ea typeface="Inter" pitchFamily="34" charset="-122"/>
                 <a:cs typeface="Inter" pitchFamily="34" charset="-120"/>
               </a:rPr>
-              <a:t>63.8%  →  </a:t>
+              <a:t>45.7%  →  </a:t>
             </a:r>
             <a:pPr indent="0" marL="0">
               <a:spcAft>
@@ -19191,30 +19309,30 @@
               <a:buNone/>
             </a:pPr>
             <a:r>
-              <a:rPr lang="en-US" sz="1200" b="1" dirty="0">
-                <a:solidFill>
-                  <a:srgbClr val="A82B26"/>
-                </a:solidFill>
-                <a:latin typeface="Inter" pitchFamily="34" charset="0"/>
-                <a:ea typeface="Inter" pitchFamily="34" charset="-122"/>
-                <a:cs typeface="Inter" pitchFamily="34" charset="-120"/>
-              </a:rPr>
-              <a:t>57.3%</a:t>
-            </a:r>
-            <a:endParaRPr lang="en-US" sz="1400" dirty="0"/>
-          </a:p>
-        </p:txBody>
-      </p:sp>
-      <p:sp>
-        <p:nvSpPr>
-          <p:cNvPr id="41" name="Text 39"/>
-          <p:cNvSpPr txBox="1"/>
-          <p:nvPr/>
-        </p:nvSpPr>
-        <p:spPr>
-          <a:xfrm>
-            <a:off x="6632448" y="3760013"/>
-            <a:ext cx="1115568" cy="828446"/>
+              <a:rPr lang="en-US" sz="1400" b="1" dirty="0">
+                <a:solidFill>
+                  <a:srgbClr val="0B7A4A"/>
+                </a:solidFill>
+                <a:latin typeface="Inter" pitchFamily="34" charset="0"/>
+                <a:ea typeface="Inter" pitchFamily="34" charset="-122"/>
+                <a:cs typeface="Inter" pitchFamily="34" charset="-120"/>
+              </a:rPr>
+              <a:t>52.5%</a:t>
+            </a:r>
+            <a:endParaRPr lang="en-US" sz="1700" dirty="0"/>
+          </a:p>
+        </p:txBody>
+      </p:sp>
+      <p:sp>
+        <p:nvSpPr>
+          <p:cNvPr id="45" name="Text 43"/>
+          <p:cNvSpPr txBox="1"/>
+          <p:nvPr/>
+        </p:nvSpPr>
+        <p:spPr>
+          <a:xfrm>
+            <a:off x="10506456" y="3483864"/>
+            <a:ext cx="932688" cy="1380744"/>
           </a:xfrm>
           <a:prstGeom prst="rect">
             <a:avLst/>
@@ -19230,50 +19348,50 @@
               <a:buNone/>
             </a:pPr>
             <a:r>
-              <a:rPr lang="en-US" sz="1600" b="1" dirty="0">
-                <a:solidFill>
-                  <a:srgbClr val="A82B26"/>
-                </a:solidFill>
-                <a:latin typeface="Inter" pitchFamily="34" charset="0"/>
-                <a:ea typeface="Inter" pitchFamily="34" charset="-122"/>
-                <a:cs typeface="Inter" pitchFamily="34" charset="-120"/>
-              </a:rPr>
-              <a:t>−6.5 pts</a:t>
-            </a:r>
-            <a:endParaRPr lang="en-US" sz="1600" dirty="0"/>
-          </a:p>
-        </p:txBody>
-      </p:sp>
-      <p:sp>
-        <p:nvSpPr>
-          <p:cNvPr id="42" name="Shape 40"/>
+              <a:rPr lang="en-US" sz="1800" b="1" dirty="0">
+                <a:solidFill>
+                  <a:srgbClr val="0B7A4A"/>
+                </a:solidFill>
+                <a:latin typeface="Inter" pitchFamily="34" charset="0"/>
+                <a:ea typeface="Inter" pitchFamily="34" charset="-122"/>
+                <a:cs typeface="Inter" pitchFamily="34" charset="-120"/>
+              </a:rPr>
+              <a:t>+6.8 pts</a:t>
+            </a:r>
+            <a:endParaRPr lang="en-US" sz="1800" dirty="0"/>
+          </a:p>
+        </p:txBody>
+      </p:sp>
+      <p:sp>
+        <p:nvSpPr>
+          <p:cNvPr id="46" name="Shape 44"/>
           <p:cNvSpPr/>
           <p:nvPr/>
         </p:nvSpPr>
         <p:spPr>
           <a:xfrm>
-            <a:off x="7775448" y="4625035"/>
-            <a:ext cx="64008" cy="755294"/>
-          </a:xfrm>
-          <a:prstGeom prst="rect">
-            <a:avLst/>
-          </a:prstGeom>
-          <a:solidFill>
-            <a:srgbClr val="2587C5"/>
-          </a:solidFill>
-          <a:ln/>
-        </p:spPr>
-      </p:sp>
-      <p:sp>
-        <p:nvSpPr>
-          <p:cNvPr id="43" name="Text 41"/>
-          <p:cNvSpPr txBox="1"/>
-          <p:nvPr/>
-        </p:nvSpPr>
-        <p:spPr>
-          <a:xfrm>
-            <a:off x="4440936" y="4588459"/>
-            <a:ext cx="365760" cy="828446"/>
+            <a:off x="8040624" y="4864608"/>
+            <a:ext cx="3489960" cy="1380744"/>
+          </a:xfrm>
+          <a:prstGeom prst="rect">
+            <a:avLst/>
+          </a:prstGeom>
+          <a:solidFill>
+            <a:srgbClr val="F7F7F7"/>
+          </a:solidFill>
+          <a:ln/>
+        </p:spPr>
+      </p:sp>
+      <p:sp>
+        <p:nvSpPr>
+          <p:cNvPr id="47" name="Text 45"/>
+          <p:cNvSpPr txBox="1"/>
+          <p:nvPr/>
+        </p:nvSpPr>
+        <p:spPr>
+          <a:xfrm>
+            <a:off x="8132064" y="4864608"/>
+            <a:ext cx="365760" cy="1380744"/>
           </a:xfrm>
           <a:prstGeom prst="rect">
             <a:avLst/>
@@ -19289,7 +19407,7 @@
               <a:buNone/>
             </a:pPr>
             <a:r>
-              <a:rPr lang="en-US" sz="1500" b="1" dirty="0">
+              <a:rPr lang="en-US" sz="2000" b="1" dirty="0">
                 <a:solidFill>
                   <a:srgbClr val="0B2C4A"/>
                 </a:solidFill>
@@ -19297,22 +19415,22 @@
                 <a:ea typeface="Inter" pitchFamily="34" charset="-122"/>
                 <a:cs typeface="Inter" pitchFamily="34" charset="-120"/>
               </a:rPr>
-              <a:t>30</a:t>
-            </a:r>
-            <a:endParaRPr lang="en-US" sz="1500" dirty="0"/>
-          </a:p>
-        </p:txBody>
-      </p:sp>
-      <p:sp>
-        <p:nvSpPr>
-          <p:cNvPr id="44" name="Text 42"/>
-          <p:cNvSpPr txBox="1"/>
-          <p:nvPr/>
-        </p:nvSpPr>
-        <p:spPr>
-          <a:xfrm>
-            <a:off x="4788408" y="4588459"/>
-            <a:ext cx="1825752" cy="828446"/>
+              <a:t>3</a:t>
+            </a:r>
+            <a:endParaRPr lang="en-US" sz="2000" dirty="0"/>
+          </a:p>
+        </p:txBody>
+      </p:sp>
+      <p:sp>
+        <p:nvSpPr>
+          <p:cNvPr id="48" name="Text 46"/>
+          <p:cNvSpPr txBox="1"/>
+          <p:nvPr/>
+        </p:nvSpPr>
+        <p:spPr>
+          <a:xfrm>
+            <a:off x="8543544" y="4864608"/>
+            <a:ext cx="1917192" cy="1380744"/>
           </a:xfrm>
           <a:prstGeom prst="rect">
             <a:avLst/>
@@ -19331,7 +19449,7 @@
               <a:buNone/>
             </a:pPr>
             <a:r>
-              <a:rPr lang="en-US" sz="1400" b="1" dirty="0">
+              <a:rPr lang="en-US" sz="1700" b="1" dirty="0">
                 <a:solidFill>
                   <a:srgbClr val="1A1A1A"/>
                 </a:solidFill>
@@ -19339,9 +19457,9 @@
                 <a:ea typeface="Inter" pitchFamily="34" charset="-122"/>
                 <a:cs typeface="Inter" pitchFamily="34" charset="-120"/>
               </a:rPr>
-              <a:t>Audi Henderson</a:t>
-            </a:r>
-            <a:endParaRPr lang="en-US" sz="1400" dirty="0"/>
+              <a:t>Chevy GMC Bullhead</a:t>
+            </a:r>
+            <a:endParaRPr lang="en-US" sz="1700" dirty="0"/>
           </a:p>
           <a:p>
             <a:pPr indent="0" marL="0">
@@ -19351,7 +19469,7 @@
               <a:buNone/>
             </a:pPr>
             <a:r>
-              <a:rPr lang="en-US" sz="1200" dirty="0">
+              <a:rPr lang="en-US" sz="1400" dirty="0">
                 <a:solidFill>
                   <a:srgbClr val="595959"/>
                 </a:solidFill>
@@ -19359,7 +19477,7 @@
                 <a:ea typeface="Inter" pitchFamily="34" charset="-122"/>
                 <a:cs typeface="Inter" pitchFamily="34" charset="-120"/>
               </a:rPr>
-              <a:t>39.8%  →  </a:t>
+              <a:t>42.2%  →  </a:t>
             </a:r>
             <a:pPr indent="0" marL="0">
               <a:spcAft>
@@ -19368,30 +19486,30 @@
               <a:buNone/>
             </a:pPr>
             <a:r>
-              <a:rPr lang="en-US" sz="1200" b="1" dirty="0">
-                <a:solidFill>
-                  <a:srgbClr val="A82B26"/>
-                </a:solidFill>
-                <a:latin typeface="Inter" pitchFamily="34" charset="0"/>
-                <a:ea typeface="Inter" pitchFamily="34" charset="-122"/>
-                <a:cs typeface="Inter" pitchFamily="34" charset="-120"/>
-              </a:rPr>
-              <a:t>34.1%</a:t>
-            </a:r>
-            <a:endParaRPr lang="en-US" sz="1400" dirty="0"/>
-          </a:p>
-        </p:txBody>
-      </p:sp>
-      <p:sp>
-        <p:nvSpPr>
-          <p:cNvPr id="45" name="Text 43"/>
-          <p:cNvSpPr txBox="1"/>
-          <p:nvPr/>
-        </p:nvSpPr>
-        <p:spPr>
-          <a:xfrm>
-            <a:off x="6632448" y="4588459"/>
-            <a:ext cx="1115568" cy="828446"/>
+              <a:rPr lang="en-US" sz="1400" b="1" dirty="0">
+                <a:solidFill>
+                  <a:srgbClr val="0B7A4A"/>
+                </a:solidFill>
+                <a:latin typeface="Inter" pitchFamily="34" charset="0"/>
+                <a:ea typeface="Inter" pitchFamily="34" charset="-122"/>
+                <a:cs typeface="Inter" pitchFamily="34" charset="-120"/>
+              </a:rPr>
+              <a:t>48.3%</a:t>
+            </a:r>
+            <a:endParaRPr lang="en-US" sz="1700" dirty="0"/>
+          </a:p>
+        </p:txBody>
+      </p:sp>
+      <p:sp>
+        <p:nvSpPr>
+          <p:cNvPr id="49" name="Text 47"/>
+          <p:cNvSpPr txBox="1"/>
+          <p:nvPr/>
+        </p:nvSpPr>
+        <p:spPr>
+          <a:xfrm>
+            <a:off x="10506456" y="4864608"/>
+            <a:ext cx="932688" cy="1380744"/>
           </a:xfrm>
           <a:prstGeom prst="rect">
             <a:avLst/>
@@ -19407,420 +19525,7 @@
               <a:buNone/>
             </a:pPr>
             <a:r>
-              <a:rPr lang="en-US" sz="1600" b="1" dirty="0">
-                <a:solidFill>
-                  <a:srgbClr val="A82B26"/>
-                </a:solidFill>
-                <a:latin typeface="Inter" pitchFamily="34" charset="0"/>
-                <a:ea typeface="Inter" pitchFamily="34" charset="-122"/>
-                <a:cs typeface="Inter" pitchFamily="34" charset="-120"/>
-              </a:rPr>
-              <a:t>−5.7 pts</a:t>
-            </a:r>
-            <a:endParaRPr lang="en-US" sz="1600" dirty="0"/>
-          </a:p>
-        </p:txBody>
-      </p:sp>
-      <p:sp>
-        <p:nvSpPr>
-          <p:cNvPr id="46" name="Shape 44"/>
-          <p:cNvSpPr/>
-          <p:nvPr/>
-        </p:nvSpPr>
-        <p:spPr>
-          <a:xfrm>
-            <a:off x="4349496" y="5416906"/>
-            <a:ext cx="3489960" cy="828446"/>
-          </a:xfrm>
-          <a:prstGeom prst="rect">
-            <a:avLst/>
-          </a:prstGeom>
-          <a:solidFill>
-            <a:srgbClr val="F7F7F7"/>
-          </a:solidFill>
-          <a:ln/>
-        </p:spPr>
-      </p:sp>
-      <p:sp>
-        <p:nvSpPr>
-          <p:cNvPr id="47" name="Text 45"/>
-          <p:cNvSpPr txBox="1"/>
-          <p:nvPr/>
-        </p:nvSpPr>
-        <p:spPr>
-          <a:xfrm>
-            <a:off x="4440936" y="5416906"/>
-            <a:ext cx="365760" cy="828446"/>
-          </a:xfrm>
-          <a:prstGeom prst="rect">
-            <a:avLst/>
-          </a:prstGeom>
-          <a:noFill/>
-          <a:ln/>
-        </p:spPr>
-        <p:txBody>
-          <a:bodyPr wrap="square" lIns="0" tIns="0" rIns="0" bIns="0" rtlCol="0" anchor="ctr"/>
-          <a:lstStyle/>
-          <a:p>
-            <a:pPr indent="0" marL="0">
-              <a:buNone/>
-            </a:pPr>
-            <a:r>
-              <a:rPr lang="en-US" sz="1500" b="1" dirty="0">
-                <a:solidFill>
-                  <a:srgbClr val="0B2C4A"/>
-                </a:solidFill>
-                <a:latin typeface="Inter" pitchFamily="34" charset="0"/>
-                <a:ea typeface="Inter" pitchFamily="34" charset="-122"/>
-                <a:cs typeface="Inter" pitchFamily="34" charset="-120"/>
-              </a:rPr>
-              <a:t>29</a:t>
-            </a:r>
-            <a:endParaRPr lang="en-US" sz="1500" dirty="0"/>
-          </a:p>
-        </p:txBody>
-      </p:sp>
-      <p:sp>
-        <p:nvSpPr>
-          <p:cNvPr id="48" name="Text 46"/>
-          <p:cNvSpPr txBox="1"/>
-          <p:nvPr/>
-        </p:nvSpPr>
-        <p:spPr>
-          <a:xfrm>
-            <a:off x="4788408" y="5416906"/>
-            <a:ext cx="1825752" cy="828446"/>
-          </a:xfrm>
-          <a:prstGeom prst="rect">
-            <a:avLst/>
-          </a:prstGeom>
-          <a:noFill/>
-          <a:ln/>
-        </p:spPr>
-        <p:txBody>
-          <a:bodyPr wrap="square" lIns="0" tIns="0" rIns="0" bIns="0" rtlCol="0" anchor="ctr"/>
-          <a:lstStyle/>
-          <a:p>
-            <a:pPr indent="0" marL="0">
-              <a:spcAft>
-                <a:spcPts val="200"/>
-              </a:spcAft>
-              <a:buNone/>
-            </a:pPr>
-            <a:r>
-              <a:rPr lang="en-US" sz="1400" b="1" dirty="0">
-                <a:solidFill>
-                  <a:srgbClr val="1A1A1A"/>
-                </a:solidFill>
-                <a:latin typeface="Inter" pitchFamily="34" charset="0"/>
-                <a:ea typeface="Inter" pitchFamily="34" charset="-122"/>
-                <a:cs typeface="Inter" pitchFamily="34" charset="-120"/>
-              </a:rPr>
-              <a:t>Cadillac</a:t>
-            </a:r>
-            <a:endParaRPr lang="en-US" sz="1400" dirty="0"/>
-          </a:p>
-          <a:p>
-            <a:pPr indent="0" marL="0">
-              <a:spcAft>
-                <a:spcPts val="200"/>
-              </a:spcAft>
-              <a:buNone/>
-            </a:pPr>
-            <a:r>
-              <a:rPr lang="en-US" sz="1200" dirty="0">
-                <a:solidFill>
-                  <a:srgbClr val="595959"/>
-                </a:solidFill>
-                <a:latin typeface="Inter" pitchFamily="34" charset="0"/>
-                <a:ea typeface="Inter" pitchFamily="34" charset="-122"/>
-                <a:cs typeface="Inter" pitchFamily="34" charset="-120"/>
-              </a:rPr>
-              <a:t>32.0%  →  </a:t>
-            </a:r>
-            <a:pPr indent="0" marL="0">
-              <a:spcAft>
-                <a:spcPts val="200"/>
-              </a:spcAft>
-              <a:buNone/>
-            </a:pPr>
-            <a:r>
-              <a:rPr lang="en-US" sz="1200" b="1" dirty="0">
-                <a:solidFill>
-                  <a:srgbClr val="A82B26"/>
-                </a:solidFill>
-                <a:latin typeface="Inter" pitchFamily="34" charset="0"/>
-                <a:ea typeface="Inter" pitchFamily="34" charset="-122"/>
-                <a:cs typeface="Inter" pitchFamily="34" charset="-120"/>
-              </a:rPr>
-              <a:t>27.9%</a:t>
-            </a:r>
-            <a:endParaRPr lang="en-US" sz="1400" dirty="0"/>
-          </a:p>
-        </p:txBody>
-      </p:sp>
-      <p:sp>
-        <p:nvSpPr>
-          <p:cNvPr id="49" name="Text 47"/>
-          <p:cNvSpPr txBox="1"/>
-          <p:nvPr/>
-        </p:nvSpPr>
-        <p:spPr>
-          <a:xfrm>
-            <a:off x="6632448" y="5416906"/>
-            <a:ext cx="1115568" cy="828446"/>
-          </a:xfrm>
-          <a:prstGeom prst="rect">
-            <a:avLst/>
-          </a:prstGeom>
-          <a:noFill/>
-          <a:ln/>
-        </p:spPr>
-        <p:txBody>
-          <a:bodyPr wrap="square" lIns="0" tIns="0" rIns="0" bIns="0" rtlCol="0" anchor="ctr"/>
-          <a:lstStyle/>
-          <a:p>
-            <a:pPr algn="r" indent="0" marL="0">
-              <a:buNone/>
-            </a:pPr>
-            <a:r>
-              <a:rPr lang="en-US" sz="1600" b="1" dirty="0">
-                <a:solidFill>
-                  <a:srgbClr val="A82B26"/>
-                </a:solidFill>
-                <a:latin typeface="Inter" pitchFamily="34" charset="0"/>
-                <a:ea typeface="Inter" pitchFamily="34" charset="-122"/>
-                <a:cs typeface="Inter" pitchFamily="34" charset="-120"/>
-              </a:rPr>
-              <a:t>−4.1 pts</a:t>
-            </a:r>
-            <a:endParaRPr lang="en-US" sz="1600" dirty="0"/>
-          </a:p>
-        </p:txBody>
-      </p:sp>
-      <p:sp>
-        <p:nvSpPr>
-          <p:cNvPr id="50" name="Shape 48"/>
-          <p:cNvSpPr/>
-          <p:nvPr/>
-        </p:nvSpPr>
-        <p:spPr>
-          <a:xfrm>
-            <a:off x="8040624" y="1371600"/>
-            <a:ext cx="3489960" cy="45720"/>
-          </a:xfrm>
-          <a:prstGeom prst="rect">
-            <a:avLst/>
-          </a:prstGeom>
-          <a:solidFill>
-            <a:srgbClr val="2587C5"/>
-          </a:solidFill>
-          <a:ln/>
-        </p:spPr>
-      </p:sp>
-      <p:sp>
-        <p:nvSpPr>
-          <p:cNvPr id="51" name="Text 49"/>
-          <p:cNvSpPr txBox="1"/>
-          <p:nvPr/>
-        </p:nvSpPr>
-        <p:spPr>
-          <a:xfrm>
-            <a:off x="8132064" y="1444752"/>
-            <a:ext cx="3307080" cy="274320"/>
-          </a:xfrm>
-          <a:prstGeom prst="rect">
-            <a:avLst/>
-          </a:prstGeom>
-          <a:noFill/>
-          <a:ln/>
-        </p:spPr>
-        <p:txBody>
-          <a:bodyPr wrap="square" lIns="0" tIns="0" rIns="0" bIns="0" rtlCol="0" anchor="ctr"/>
-          <a:lstStyle/>
-          <a:p>
-            <a:pPr indent="0" marL="0">
-              <a:buNone/>
-            </a:pPr>
-            <a:r>
-              <a:rPr lang="en-US" sz="1500" b="1" spc="100" kern="0" dirty="0">
-                <a:solidFill>
-                  <a:srgbClr val="0B2C4A"/>
-                </a:solidFill>
-                <a:latin typeface="Inter" pitchFamily="34" charset="0"/>
-                <a:ea typeface="Inter" pitchFamily="34" charset="-122"/>
-                <a:cs typeface="Inter" pitchFamily="34" charset="-120"/>
-              </a:rPr>
-              <a:t>TOP 5 MOVING NOW</a:t>
-            </a:r>
-            <a:endParaRPr lang="en-US" sz="1500" dirty="0"/>
-          </a:p>
-        </p:txBody>
-      </p:sp>
-      <p:sp>
-        <p:nvSpPr>
-          <p:cNvPr id="52" name="Text 50"/>
-          <p:cNvSpPr txBox="1"/>
-          <p:nvPr/>
-        </p:nvSpPr>
-        <p:spPr>
-          <a:xfrm>
-            <a:off x="8132064" y="1737360"/>
-            <a:ext cx="3307080" cy="274320"/>
-          </a:xfrm>
-          <a:prstGeom prst="rect">
-            <a:avLst/>
-          </a:prstGeom>
-          <a:noFill/>
-          <a:ln/>
-        </p:spPr>
-        <p:txBody>
-          <a:bodyPr wrap="square" lIns="0" tIns="0" rIns="0" bIns="0" rtlCol="0" anchor="ctr"/>
-          <a:lstStyle/>
-          <a:p>
-            <a:pPr indent="0" marL="0">
-              <a:buNone/>
-            </a:pPr>
-            <a:r>
-              <a:rPr lang="en-US" sz="1200" dirty="0">
-                <a:solidFill>
-                  <a:srgbClr val="595959"/>
-                </a:solidFill>
-                <a:latin typeface="Inter" pitchFamily="34" charset="0"/>
-                <a:ea typeface="Inter" pitchFamily="34" charset="-122"/>
-                <a:cs typeface="Inter" pitchFamily="34" charset="-120"/>
-              </a:rPr>
-              <a:t>Q3 vs Q1, this year</a:t>
-            </a:r>
-            <a:endParaRPr lang="en-US" sz="1200" dirty="0"/>
-          </a:p>
-        </p:txBody>
-      </p:sp>
-      <p:sp>
-        <p:nvSpPr>
-          <p:cNvPr id="53" name="Shape 51"/>
-          <p:cNvSpPr/>
-          <p:nvPr/>
-        </p:nvSpPr>
-        <p:spPr>
-          <a:xfrm>
-            <a:off x="8040624" y="2103120"/>
-            <a:ext cx="3489960" cy="828446"/>
-          </a:xfrm>
-          <a:prstGeom prst="rect">
-            <a:avLst/>
-          </a:prstGeom>
-          <a:solidFill>
-            <a:srgbClr val="F7F7F7"/>
-          </a:solidFill>
-          <a:ln/>
-        </p:spPr>
-      </p:sp>
-      <p:sp>
-        <p:nvSpPr>
-          <p:cNvPr id="54" name="Text 52"/>
-          <p:cNvSpPr txBox="1"/>
-          <p:nvPr/>
-        </p:nvSpPr>
-        <p:spPr>
-          <a:xfrm>
-            <a:off x="8132064" y="2103120"/>
-            <a:ext cx="365760" cy="828446"/>
-          </a:xfrm>
-          <a:prstGeom prst="rect">
-            <a:avLst/>
-          </a:prstGeom>
-          <a:noFill/>
-          <a:ln/>
-        </p:spPr>
-        <p:txBody>
-          <a:bodyPr wrap="square" lIns="0" tIns="0" rIns="0" bIns="0" rtlCol="0" anchor="ctr"/>
-          <a:lstStyle/>
-          <a:p>
-            <a:pPr indent="0" marL="0">
-              <a:buNone/>
-            </a:pPr>
-            <a:r>
-              <a:rPr lang="en-US" sz="1500" b="1" dirty="0">
-                <a:solidFill>
-                  <a:srgbClr val="0B2C4A"/>
-                </a:solidFill>
-                <a:latin typeface="Inter" pitchFamily="34" charset="0"/>
-                <a:ea typeface="Inter" pitchFamily="34" charset="-122"/>
-                <a:cs typeface="Inter" pitchFamily="34" charset="-120"/>
-              </a:rPr>
-              <a:t>1</a:t>
-            </a:r>
-            <a:endParaRPr lang="en-US" sz="1500" dirty="0"/>
-          </a:p>
-        </p:txBody>
-      </p:sp>
-      <p:sp>
-        <p:nvSpPr>
-          <p:cNvPr id="55" name="Text 53"/>
-          <p:cNvSpPr txBox="1"/>
-          <p:nvPr/>
-        </p:nvSpPr>
-        <p:spPr>
-          <a:xfrm>
-            <a:off x="8479536" y="2103120"/>
-            <a:ext cx="1825752" cy="828446"/>
-          </a:xfrm>
-          <a:prstGeom prst="rect">
-            <a:avLst/>
-          </a:prstGeom>
-          <a:noFill/>
-          <a:ln/>
-        </p:spPr>
-        <p:txBody>
-          <a:bodyPr wrap="square" lIns="0" tIns="0" rIns="0" bIns="0" rtlCol="0" anchor="ctr"/>
-          <a:lstStyle/>
-          <a:p>
-            <a:pPr indent="0" marL="0">
-              <a:spcAft>
-                <a:spcPts val="200"/>
-              </a:spcAft>
-              <a:buNone/>
-            </a:pPr>
-            <a:r>
-              <a:rPr lang="en-US" sz="1400" b="1" dirty="0">
-                <a:solidFill>
-                  <a:srgbClr val="1A1A1A"/>
-                </a:solidFill>
-                <a:latin typeface="Inter" pitchFamily="34" charset="0"/>
-                <a:ea typeface="Inter" pitchFamily="34" charset="-122"/>
-                <a:cs typeface="Inter" pitchFamily="34" charset="-120"/>
-              </a:rPr>
-              <a:t>Lexus</a:t>
-            </a:r>
-            <a:endParaRPr lang="en-US" sz="1400" dirty="0"/>
-          </a:p>
-          <a:p>
-            <a:pPr indent="0" marL="0">
-              <a:spcAft>
-                <a:spcPts val="200"/>
-              </a:spcAft>
-              <a:buNone/>
-            </a:pPr>
-            <a:r>
-              <a:rPr lang="en-US" sz="1200" dirty="0">
-                <a:solidFill>
-                  <a:srgbClr val="595959"/>
-                </a:solidFill>
-                <a:latin typeface="Inter" pitchFamily="34" charset="0"/>
-                <a:ea typeface="Inter" pitchFamily="34" charset="-122"/>
-                <a:cs typeface="Inter" pitchFamily="34" charset="-120"/>
-              </a:rPr>
-              <a:t>48.9%  →  </a:t>
-            </a:r>
-            <a:pPr indent="0" marL="0">
-              <a:spcAft>
-                <a:spcPts val="200"/>
-              </a:spcAft>
-              <a:buNone/>
-            </a:pPr>
-            <a:r>
-              <a:rPr lang="en-US" sz="1200" b="1" dirty="0">
+              <a:rPr lang="en-US" sz="1800" b="1" dirty="0">
                 <a:solidFill>
                   <a:srgbClr val="0B7A4A"/>
                 </a:solidFill>
@@ -19828,756 +19533,9 @@
                 <a:ea typeface="Inter" pitchFamily="34" charset="-122"/>
                 <a:cs typeface="Inter" pitchFamily="34" charset="-120"/>
               </a:rPr>
-              <a:t>57.7%</a:t>
-            </a:r>
-            <a:endParaRPr lang="en-US" sz="1400" dirty="0"/>
-          </a:p>
-        </p:txBody>
-      </p:sp>
-      <p:sp>
-        <p:nvSpPr>
-          <p:cNvPr id="56" name="Text 54"/>
-          <p:cNvSpPr txBox="1"/>
-          <p:nvPr/>
-        </p:nvSpPr>
-        <p:spPr>
-          <a:xfrm>
-            <a:off x="10323576" y="2103120"/>
-            <a:ext cx="1115568" cy="828446"/>
-          </a:xfrm>
-          <a:prstGeom prst="rect">
-            <a:avLst/>
-          </a:prstGeom>
-          <a:noFill/>
-          <a:ln/>
-        </p:spPr>
-        <p:txBody>
-          <a:bodyPr wrap="square" lIns="0" tIns="0" rIns="0" bIns="0" rtlCol="0" anchor="ctr"/>
-          <a:lstStyle/>
-          <a:p>
-            <a:pPr algn="r" indent="0" marL="0">
-              <a:buNone/>
-            </a:pPr>
-            <a:r>
-              <a:rPr lang="en-US" sz="1600" b="1" dirty="0">
-                <a:solidFill>
-                  <a:srgbClr val="0B7A4A"/>
-                </a:solidFill>
-                <a:latin typeface="Inter" pitchFamily="34" charset="0"/>
-                <a:ea typeface="Inter" pitchFamily="34" charset="-122"/>
-                <a:cs typeface="Inter" pitchFamily="34" charset="-120"/>
-              </a:rPr>
-              <a:t>+8.8 pts</a:t>
-            </a:r>
-            <a:endParaRPr lang="en-US" sz="1600" dirty="0"/>
-          </a:p>
-        </p:txBody>
-      </p:sp>
-      <p:sp>
-        <p:nvSpPr>
-          <p:cNvPr id="57" name="Shape 55"/>
-          <p:cNvSpPr/>
-          <p:nvPr/>
-        </p:nvSpPr>
-        <p:spPr>
-          <a:xfrm>
-            <a:off x="11466576" y="2968142"/>
-            <a:ext cx="64008" cy="755294"/>
-          </a:xfrm>
-          <a:prstGeom prst="rect">
-            <a:avLst/>
-          </a:prstGeom>
-          <a:solidFill>
-            <a:srgbClr val="12A566"/>
-          </a:solidFill>
-          <a:ln/>
-        </p:spPr>
-      </p:sp>
-      <p:sp>
-        <p:nvSpPr>
-          <p:cNvPr id="58" name="Text 56"/>
-          <p:cNvSpPr txBox="1"/>
-          <p:nvPr/>
-        </p:nvSpPr>
-        <p:spPr>
-          <a:xfrm>
-            <a:off x="8132064" y="2931566"/>
-            <a:ext cx="365760" cy="828446"/>
-          </a:xfrm>
-          <a:prstGeom prst="rect">
-            <a:avLst/>
-          </a:prstGeom>
-          <a:noFill/>
-          <a:ln/>
-        </p:spPr>
-        <p:txBody>
-          <a:bodyPr wrap="square" lIns="0" tIns="0" rIns="0" bIns="0" rtlCol="0" anchor="ctr"/>
-          <a:lstStyle/>
-          <a:p>
-            <a:pPr indent="0" marL="0">
-              <a:buNone/>
-            </a:pPr>
-            <a:r>
-              <a:rPr lang="en-US" sz="1500" b="1" dirty="0">
-                <a:solidFill>
-                  <a:srgbClr val="0B2C4A"/>
-                </a:solidFill>
-                <a:latin typeface="Inter" pitchFamily="34" charset="0"/>
-                <a:ea typeface="Inter" pitchFamily="34" charset="-122"/>
-                <a:cs typeface="Inter" pitchFamily="34" charset="-120"/>
-              </a:rPr>
-              <a:t>2</a:t>
-            </a:r>
-            <a:endParaRPr lang="en-US" sz="1500" dirty="0"/>
-          </a:p>
-        </p:txBody>
-      </p:sp>
-      <p:sp>
-        <p:nvSpPr>
-          <p:cNvPr id="59" name="Text 57"/>
-          <p:cNvSpPr txBox="1"/>
-          <p:nvPr/>
-        </p:nvSpPr>
-        <p:spPr>
-          <a:xfrm>
-            <a:off x="8479536" y="2931566"/>
-            <a:ext cx="1825752" cy="828446"/>
-          </a:xfrm>
-          <a:prstGeom prst="rect">
-            <a:avLst/>
-          </a:prstGeom>
-          <a:noFill/>
-          <a:ln/>
-        </p:spPr>
-        <p:txBody>
-          <a:bodyPr wrap="square" lIns="0" tIns="0" rIns="0" bIns="0" rtlCol="0" anchor="ctr"/>
-          <a:lstStyle/>
-          <a:p>
-            <a:pPr indent="0" marL="0">
-              <a:spcAft>
-                <a:spcPts val="200"/>
-              </a:spcAft>
-              <a:buNone/>
-            </a:pPr>
-            <a:r>
-              <a:rPr lang="en-US" sz="1400" b="1" dirty="0">
-                <a:solidFill>
-                  <a:srgbClr val="1A1A1A"/>
-                </a:solidFill>
-                <a:latin typeface="Inter" pitchFamily="34" charset="0"/>
-                <a:ea typeface="Inter" pitchFamily="34" charset="-122"/>
-                <a:cs typeface="Inter" pitchFamily="34" charset="-120"/>
-              </a:rPr>
-              <a:t>Acura</a:t>
-            </a:r>
-            <a:endParaRPr lang="en-US" sz="1400" dirty="0"/>
-          </a:p>
-          <a:p>
-            <a:pPr indent="0" marL="0">
-              <a:spcAft>
-                <a:spcPts val="200"/>
-              </a:spcAft>
-              <a:buNone/>
-            </a:pPr>
-            <a:r>
-              <a:rPr lang="en-US" sz="1200" dirty="0">
-                <a:solidFill>
-                  <a:srgbClr val="595959"/>
-                </a:solidFill>
-                <a:latin typeface="Inter" pitchFamily="34" charset="0"/>
-                <a:ea typeface="Inter" pitchFamily="34" charset="-122"/>
-                <a:cs typeface="Inter" pitchFamily="34" charset="-120"/>
-              </a:rPr>
-              <a:t>45.7%  →  </a:t>
-            </a:r>
-            <a:pPr indent="0" marL="0">
-              <a:spcAft>
-                <a:spcPts val="200"/>
-              </a:spcAft>
-              <a:buNone/>
-            </a:pPr>
-            <a:r>
-              <a:rPr lang="en-US" sz="1200" b="1" dirty="0">
-                <a:solidFill>
-                  <a:srgbClr val="0B7A4A"/>
-                </a:solidFill>
-                <a:latin typeface="Inter" pitchFamily="34" charset="0"/>
-                <a:ea typeface="Inter" pitchFamily="34" charset="-122"/>
-                <a:cs typeface="Inter" pitchFamily="34" charset="-120"/>
-              </a:rPr>
-              <a:t>52.5%</a:t>
-            </a:r>
-            <a:endParaRPr lang="en-US" sz="1400" dirty="0"/>
-          </a:p>
-        </p:txBody>
-      </p:sp>
-      <p:sp>
-        <p:nvSpPr>
-          <p:cNvPr id="60" name="Text 58"/>
-          <p:cNvSpPr txBox="1"/>
-          <p:nvPr/>
-        </p:nvSpPr>
-        <p:spPr>
-          <a:xfrm>
-            <a:off x="10323576" y="2931566"/>
-            <a:ext cx="1115568" cy="828446"/>
-          </a:xfrm>
-          <a:prstGeom prst="rect">
-            <a:avLst/>
-          </a:prstGeom>
-          <a:noFill/>
-          <a:ln/>
-        </p:spPr>
-        <p:txBody>
-          <a:bodyPr wrap="square" lIns="0" tIns="0" rIns="0" bIns="0" rtlCol="0" anchor="ctr"/>
-          <a:lstStyle/>
-          <a:p>
-            <a:pPr algn="r" indent="0" marL="0">
-              <a:buNone/>
-            </a:pPr>
-            <a:r>
-              <a:rPr lang="en-US" sz="1600" b="1" dirty="0">
-                <a:solidFill>
-                  <a:srgbClr val="0B7A4A"/>
-                </a:solidFill>
-                <a:latin typeface="Inter" pitchFamily="34" charset="0"/>
-                <a:ea typeface="Inter" pitchFamily="34" charset="-122"/>
-                <a:cs typeface="Inter" pitchFamily="34" charset="-120"/>
-              </a:rPr>
-              <a:t>+6.8 pts</a:t>
-            </a:r>
-            <a:endParaRPr lang="en-US" sz="1600" dirty="0"/>
-          </a:p>
-        </p:txBody>
-      </p:sp>
-      <p:sp>
-        <p:nvSpPr>
-          <p:cNvPr id="61" name="Shape 59"/>
-          <p:cNvSpPr/>
-          <p:nvPr/>
-        </p:nvSpPr>
-        <p:spPr>
-          <a:xfrm>
-            <a:off x="8040624" y="3760013"/>
-            <a:ext cx="3489960" cy="828446"/>
-          </a:xfrm>
-          <a:prstGeom prst="rect">
-            <a:avLst/>
-          </a:prstGeom>
-          <a:solidFill>
-            <a:srgbClr val="F7F7F7"/>
-          </a:solidFill>
-          <a:ln/>
-        </p:spPr>
-      </p:sp>
-      <p:sp>
-        <p:nvSpPr>
-          <p:cNvPr id="62" name="Text 60"/>
-          <p:cNvSpPr txBox="1"/>
-          <p:nvPr/>
-        </p:nvSpPr>
-        <p:spPr>
-          <a:xfrm>
-            <a:off x="8132064" y="3760013"/>
-            <a:ext cx="365760" cy="828446"/>
-          </a:xfrm>
-          <a:prstGeom prst="rect">
-            <a:avLst/>
-          </a:prstGeom>
-          <a:noFill/>
-          <a:ln/>
-        </p:spPr>
-        <p:txBody>
-          <a:bodyPr wrap="square" lIns="0" tIns="0" rIns="0" bIns="0" rtlCol="0" anchor="ctr"/>
-          <a:lstStyle/>
-          <a:p>
-            <a:pPr indent="0" marL="0">
-              <a:buNone/>
-            </a:pPr>
-            <a:r>
-              <a:rPr lang="en-US" sz="1500" b="1" dirty="0">
-                <a:solidFill>
-                  <a:srgbClr val="0B2C4A"/>
-                </a:solidFill>
-                <a:latin typeface="Inter" pitchFamily="34" charset="0"/>
-                <a:ea typeface="Inter" pitchFamily="34" charset="-122"/>
-                <a:cs typeface="Inter" pitchFamily="34" charset="-120"/>
-              </a:rPr>
-              <a:t>3</a:t>
-            </a:r>
-            <a:endParaRPr lang="en-US" sz="1500" dirty="0"/>
-          </a:p>
-        </p:txBody>
-      </p:sp>
-      <p:sp>
-        <p:nvSpPr>
-          <p:cNvPr id="63" name="Text 61"/>
-          <p:cNvSpPr txBox="1"/>
-          <p:nvPr/>
-        </p:nvSpPr>
-        <p:spPr>
-          <a:xfrm>
-            <a:off x="8479536" y="3760013"/>
-            <a:ext cx="1825752" cy="828446"/>
-          </a:xfrm>
-          <a:prstGeom prst="rect">
-            <a:avLst/>
-          </a:prstGeom>
-          <a:noFill/>
-          <a:ln/>
-        </p:spPr>
-        <p:txBody>
-          <a:bodyPr wrap="square" lIns="0" tIns="0" rIns="0" bIns="0" rtlCol="0" anchor="ctr"/>
-          <a:lstStyle/>
-          <a:p>
-            <a:pPr indent="0" marL="0">
-              <a:spcAft>
-                <a:spcPts val="200"/>
-              </a:spcAft>
-              <a:buNone/>
-            </a:pPr>
-            <a:r>
-              <a:rPr lang="en-US" sz="1400" b="1" dirty="0">
-                <a:solidFill>
-                  <a:srgbClr val="1A1A1A"/>
-                </a:solidFill>
-                <a:latin typeface="Inter" pitchFamily="34" charset="0"/>
-                <a:ea typeface="Inter" pitchFamily="34" charset="-122"/>
-                <a:cs typeface="Inter" pitchFamily="34" charset="-120"/>
-              </a:rPr>
-              <a:t>Chevy GMC Bullhead</a:t>
-            </a:r>
-            <a:endParaRPr lang="en-US" sz="1400" dirty="0"/>
-          </a:p>
-          <a:p>
-            <a:pPr indent="0" marL="0">
-              <a:spcAft>
-                <a:spcPts val="200"/>
-              </a:spcAft>
-              <a:buNone/>
-            </a:pPr>
-            <a:r>
-              <a:rPr lang="en-US" sz="1200" dirty="0">
-                <a:solidFill>
-                  <a:srgbClr val="595959"/>
-                </a:solidFill>
-                <a:latin typeface="Inter" pitchFamily="34" charset="0"/>
-                <a:ea typeface="Inter" pitchFamily="34" charset="-122"/>
-                <a:cs typeface="Inter" pitchFamily="34" charset="-120"/>
-              </a:rPr>
-              <a:t>42.2%  →  </a:t>
-            </a:r>
-            <a:pPr indent="0" marL="0">
-              <a:spcAft>
-                <a:spcPts val="200"/>
-              </a:spcAft>
-              <a:buNone/>
-            </a:pPr>
-            <a:r>
-              <a:rPr lang="en-US" sz="1200" b="1" dirty="0">
-                <a:solidFill>
-                  <a:srgbClr val="0B7A4A"/>
-                </a:solidFill>
-                <a:latin typeface="Inter" pitchFamily="34" charset="0"/>
-                <a:ea typeface="Inter" pitchFamily="34" charset="-122"/>
-                <a:cs typeface="Inter" pitchFamily="34" charset="-120"/>
-              </a:rPr>
-              <a:t>48.3%</a:t>
-            </a:r>
-            <a:endParaRPr lang="en-US" sz="1400" dirty="0"/>
-          </a:p>
-        </p:txBody>
-      </p:sp>
-      <p:sp>
-        <p:nvSpPr>
-          <p:cNvPr id="64" name="Text 62"/>
-          <p:cNvSpPr txBox="1"/>
-          <p:nvPr/>
-        </p:nvSpPr>
-        <p:spPr>
-          <a:xfrm>
-            <a:off x="10323576" y="3760013"/>
-            <a:ext cx="1115568" cy="828446"/>
-          </a:xfrm>
-          <a:prstGeom prst="rect">
-            <a:avLst/>
-          </a:prstGeom>
-          <a:noFill/>
-          <a:ln/>
-        </p:spPr>
-        <p:txBody>
-          <a:bodyPr wrap="square" lIns="0" tIns="0" rIns="0" bIns="0" rtlCol="0" anchor="ctr"/>
-          <a:lstStyle/>
-          <a:p>
-            <a:pPr algn="r" indent="0" marL="0">
-              <a:buNone/>
-            </a:pPr>
-            <a:r>
-              <a:rPr lang="en-US" sz="1600" b="1" dirty="0">
-                <a:solidFill>
-                  <a:srgbClr val="0B7A4A"/>
-                </a:solidFill>
-                <a:latin typeface="Inter" pitchFamily="34" charset="0"/>
-                <a:ea typeface="Inter" pitchFamily="34" charset="-122"/>
-                <a:cs typeface="Inter" pitchFamily="34" charset="-120"/>
-              </a:rPr>
               <a:t>+6.1 pts</a:t>
             </a:r>
-            <a:endParaRPr lang="en-US" sz="1600" dirty="0"/>
-          </a:p>
-        </p:txBody>
-      </p:sp>
-      <p:sp>
-        <p:nvSpPr>
-          <p:cNvPr id="65" name="Text 63"/>
-          <p:cNvSpPr txBox="1"/>
-          <p:nvPr/>
-        </p:nvSpPr>
-        <p:spPr>
-          <a:xfrm>
-            <a:off x="8132064" y="4588459"/>
-            <a:ext cx="365760" cy="828446"/>
-          </a:xfrm>
-          <a:prstGeom prst="rect">
-            <a:avLst/>
-          </a:prstGeom>
-          <a:noFill/>
-          <a:ln/>
-        </p:spPr>
-        <p:txBody>
-          <a:bodyPr wrap="square" lIns="0" tIns="0" rIns="0" bIns="0" rtlCol="0" anchor="ctr"/>
-          <a:lstStyle/>
-          <a:p>
-            <a:pPr indent="0" marL="0">
-              <a:buNone/>
-            </a:pPr>
-            <a:r>
-              <a:rPr lang="en-US" sz="1500" b="1" dirty="0">
-                <a:solidFill>
-                  <a:srgbClr val="0B2C4A"/>
-                </a:solidFill>
-                <a:latin typeface="Inter" pitchFamily="34" charset="0"/>
-                <a:ea typeface="Inter" pitchFamily="34" charset="-122"/>
-                <a:cs typeface="Inter" pitchFamily="34" charset="-120"/>
-              </a:rPr>
-              <a:t>4</a:t>
-            </a:r>
-            <a:endParaRPr lang="en-US" sz="1500" dirty="0"/>
-          </a:p>
-        </p:txBody>
-      </p:sp>
-      <p:sp>
-        <p:nvSpPr>
-          <p:cNvPr id="66" name="Text 64"/>
-          <p:cNvSpPr txBox="1"/>
-          <p:nvPr/>
-        </p:nvSpPr>
-        <p:spPr>
-          <a:xfrm>
-            <a:off x="8479536" y="4588459"/>
-            <a:ext cx="1825752" cy="828446"/>
-          </a:xfrm>
-          <a:prstGeom prst="rect">
-            <a:avLst/>
-          </a:prstGeom>
-          <a:noFill/>
-          <a:ln/>
-        </p:spPr>
-        <p:txBody>
-          <a:bodyPr wrap="square" lIns="0" tIns="0" rIns="0" bIns="0" rtlCol="0" anchor="ctr"/>
-          <a:lstStyle/>
-          <a:p>
-            <a:pPr indent="0" marL="0">
-              <a:spcAft>
-                <a:spcPts val="200"/>
-              </a:spcAft>
-              <a:buNone/>
-            </a:pPr>
-            <a:r>
-              <a:rPr lang="en-US" sz="1400" b="1" dirty="0">
-                <a:solidFill>
-                  <a:srgbClr val="1A1A1A"/>
-                </a:solidFill>
-                <a:latin typeface="Inter" pitchFamily="34" charset="0"/>
-                <a:ea typeface="Inter" pitchFamily="34" charset="-122"/>
-                <a:cs typeface="Inter" pitchFamily="34" charset="-120"/>
-              </a:rPr>
-              <a:t>GMC Prescott</a:t>
-            </a:r>
-            <a:endParaRPr lang="en-US" sz="1400" dirty="0"/>
-          </a:p>
-          <a:p>
-            <a:pPr indent="0" marL="0">
-              <a:spcAft>
-                <a:spcPts val="200"/>
-              </a:spcAft>
-              <a:buNone/>
-            </a:pPr>
-            <a:r>
-              <a:rPr lang="en-US" sz="1200" dirty="0">
-                <a:solidFill>
-                  <a:srgbClr val="595959"/>
-                </a:solidFill>
-                <a:latin typeface="Inter" pitchFamily="34" charset="0"/>
-                <a:ea typeface="Inter" pitchFamily="34" charset="-122"/>
-                <a:cs typeface="Inter" pitchFamily="34" charset="-120"/>
-              </a:rPr>
-              <a:t>45.7%  →  </a:t>
-            </a:r>
-            <a:pPr indent="0" marL="0">
-              <a:spcAft>
-                <a:spcPts val="200"/>
-              </a:spcAft>
-              <a:buNone/>
-            </a:pPr>
-            <a:r>
-              <a:rPr lang="en-US" sz="1200" b="1" dirty="0">
-                <a:solidFill>
-                  <a:srgbClr val="0B7A4A"/>
-                </a:solidFill>
-                <a:latin typeface="Inter" pitchFamily="34" charset="0"/>
-                <a:ea typeface="Inter" pitchFamily="34" charset="-122"/>
-                <a:cs typeface="Inter" pitchFamily="34" charset="-120"/>
-              </a:rPr>
-              <a:t>51.5%</a:t>
-            </a:r>
-            <a:endParaRPr lang="en-US" sz="1400" dirty="0"/>
-          </a:p>
-        </p:txBody>
-      </p:sp>
-      <p:sp>
-        <p:nvSpPr>
-          <p:cNvPr id="67" name="Text 65"/>
-          <p:cNvSpPr txBox="1"/>
-          <p:nvPr/>
-        </p:nvSpPr>
-        <p:spPr>
-          <a:xfrm>
-            <a:off x="10323576" y="4588459"/>
-            <a:ext cx="1115568" cy="828446"/>
-          </a:xfrm>
-          <a:prstGeom prst="rect">
-            <a:avLst/>
-          </a:prstGeom>
-          <a:noFill/>
-          <a:ln/>
-        </p:spPr>
-        <p:txBody>
-          <a:bodyPr wrap="square" lIns="0" tIns="0" rIns="0" bIns="0" rtlCol="0" anchor="ctr"/>
-          <a:lstStyle/>
-          <a:p>
-            <a:pPr algn="r" indent="0" marL="0">
-              <a:buNone/>
-            </a:pPr>
-            <a:r>
-              <a:rPr lang="en-US" sz="1600" b="1" dirty="0">
-                <a:solidFill>
-                  <a:srgbClr val="0B7A4A"/>
-                </a:solidFill>
-                <a:latin typeface="Inter" pitchFamily="34" charset="0"/>
-                <a:ea typeface="Inter" pitchFamily="34" charset="-122"/>
-                <a:cs typeface="Inter" pitchFamily="34" charset="-120"/>
-              </a:rPr>
-              <a:t>+5.8 pts</a:t>
-            </a:r>
-            <a:endParaRPr lang="en-US" sz="1600" dirty="0"/>
-          </a:p>
-        </p:txBody>
-      </p:sp>
-      <p:sp>
-        <p:nvSpPr>
-          <p:cNvPr id="68" name="Shape 66"/>
-          <p:cNvSpPr/>
-          <p:nvPr/>
-        </p:nvSpPr>
-        <p:spPr>
-          <a:xfrm>
-            <a:off x="8040624" y="5416906"/>
-            <a:ext cx="3489960" cy="828446"/>
-          </a:xfrm>
-          <a:prstGeom prst="rect">
-            <a:avLst/>
-          </a:prstGeom>
-          <a:solidFill>
-            <a:srgbClr val="F7F7F7"/>
-          </a:solidFill>
-          <a:ln/>
-        </p:spPr>
-      </p:sp>
-      <p:sp>
-        <p:nvSpPr>
-          <p:cNvPr id="69" name="Shape 67"/>
-          <p:cNvSpPr/>
-          <p:nvPr/>
-        </p:nvSpPr>
-        <p:spPr>
-          <a:xfrm>
-            <a:off x="11466576" y="5453482"/>
-            <a:ext cx="64008" cy="755294"/>
-          </a:xfrm>
-          <a:prstGeom prst="rect">
-            <a:avLst/>
-          </a:prstGeom>
-          <a:solidFill>
-            <a:srgbClr val="2587C5"/>
-          </a:solidFill>
-          <a:ln/>
-        </p:spPr>
-      </p:sp>
-      <p:sp>
-        <p:nvSpPr>
-          <p:cNvPr id="70" name="Text 68"/>
-          <p:cNvSpPr txBox="1"/>
-          <p:nvPr/>
-        </p:nvSpPr>
-        <p:spPr>
-          <a:xfrm>
-            <a:off x="8132064" y="5416906"/>
-            <a:ext cx="365760" cy="828446"/>
-          </a:xfrm>
-          <a:prstGeom prst="rect">
-            <a:avLst/>
-          </a:prstGeom>
-          <a:noFill/>
-          <a:ln/>
-        </p:spPr>
-        <p:txBody>
-          <a:bodyPr wrap="square" lIns="0" tIns="0" rIns="0" bIns="0" rtlCol="0" anchor="ctr"/>
-          <a:lstStyle/>
-          <a:p>
-            <a:pPr indent="0" marL="0">
-              <a:buNone/>
-            </a:pPr>
-            <a:r>
-              <a:rPr lang="en-US" sz="1500" b="1" dirty="0">
-                <a:solidFill>
-                  <a:srgbClr val="0B2C4A"/>
-                </a:solidFill>
-                <a:latin typeface="Inter" pitchFamily="34" charset="0"/>
-                <a:ea typeface="Inter" pitchFamily="34" charset="-122"/>
-                <a:cs typeface="Inter" pitchFamily="34" charset="-120"/>
-              </a:rPr>
-              <a:t>5</a:t>
-            </a:r>
-            <a:endParaRPr lang="en-US" sz="1500" dirty="0"/>
-          </a:p>
-        </p:txBody>
-      </p:sp>
-      <p:sp>
-        <p:nvSpPr>
-          <p:cNvPr id="71" name="Text 69"/>
-          <p:cNvSpPr txBox="1"/>
-          <p:nvPr/>
-        </p:nvSpPr>
-        <p:spPr>
-          <a:xfrm>
-            <a:off x="8479536" y="5416906"/>
-            <a:ext cx="1825752" cy="828446"/>
-          </a:xfrm>
-          <a:prstGeom prst="rect">
-            <a:avLst/>
-          </a:prstGeom>
-          <a:noFill/>
-          <a:ln/>
-        </p:spPr>
-        <p:txBody>
-          <a:bodyPr wrap="square" lIns="0" tIns="0" rIns="0" bIns="0" rtlCol="0" anchor="ctr"/>
-          <a:lstStyle/>
-          <a:p>
-            <a:pPr indent="0" marL="0">
-              <a:spcAft>
-                <a:spcPts val="200"/>
-              </a:spcAft>
-              <a:buNone/>
-            </a:pPr>
-            <a:r>
-              <a:rPr lang="en-US" sz="1400" b="1" dirty="0">
-                <a:solidFill>
-                  <a:srgbClr val="1A1A1A"/>
-                </a:solidFill>
-                <a:latin typeface="Inter" pitchFamily="34" charset="0"/>
-                <a:ea typeface="Inter" pitchFamily="34" charset="-122"/>
-                <a:cs typeface="Inter" pitchFamily="34" charset="-120"/>
-              </a:rPr>
-              <a:t>Audi Henderson</a:t>
-            </a:r>
-            <a:endParaRPr lang="en-US" sz="1400" dirty="0"/>
-          </a:p>
-          <a:p>
-            <a:pPr indent="0" marL="0">
-              <a:spcAft>
-                <a:spcPts val="200"/>
-              </a:spcAft>
-              <a:buNone/>
-            </a:pPr>
-            <a:r>
-              <a:rPr lang="en-US" sz="1200" dirty="0">
-                <a:solidFill>
-                  <a:srgbClr val="595959"/>
-                </a:solidFill>
-                <a:latin typeface="Inter" pitchFamily="34" charset="0"/>
-                <a:ea typeface="Inter" pitchFamily="34" charset="-122"/>
-                <a:cs typeface="Inter" pitchFamily="34" charset="-120"/>
-              </a:rPr>
-              <a:t>31.3%  →  </a:t>
-            </a:r>
-            <a:pPr indent="0" marL="0">
-              <a:spcAft>
-                <a:spcPts val="200"/>
-              </a:spcAft>
-              <a:buNone/>
-            </a:pPr>
-            <a:r>
-              <a:rPr lang="en-US" sz="1200" b="1" dirty="0">
-                <a:solidFill>
-                  <a:srgbClr val="0B7A4A"/>
-                </a:solidFill>
-                <a:latin typeface="Inter" pitchFamily="34" charset="0"/>
-                <a:ea typeface="Inter" pitchFamily="34" charset="-122"/>
-                <a:cs typeface="Inter" pitchFamily="34" charset="-120"/>
-              </a:rPr>
-              <a:t>36.9%</a:t>
-            </a:r>
-            <a:endParaRPr lang="en-US" sz="1400" dirty="0"/>
-          </a:p>
-        </p:txBody>
-      </p:sp>
-      <p:sp>
-        <p:nvSpPr>
-          <p:cNvPr id="72" name="Text 70"/>
-          <p:cNvSpPr txBox="1"/>
-          <p:nvPr/>
-        </p:nvSpPr>
-        <p:spPr>
-          <a:xfrm>
-            <a:off x="10323576" y="5416906"/>
-            <a:ext cx="1115568" cy="828446"/>
-          </a:xfrm>
-          <a:prstGeom prst="rect">
-            <a:avLst/>
-          </a:prstGeom>
-          <a:noFill/>
-          <a:ln/>
-        </p:spPr>
-        <p:txBody>
-          <a:bodyPr wrap="square" lIns="0" tIns="0" rIns="0" bIns="0" rtlCol="0" anchor="ctr"/>
-          <a:lstStyle/>
-          <a:p>
-            <a:pPr algn="r" indent="0" marL="0">
-              <a:buNone/>
-            </a:pPr>
-            <a:r>
-              <a:rPr lang="en-US" sz="1600" b="1" dirty="0">
-                <a:solidFill>
-                  <a:srgbClr val="0B7A4A"/>
-                </a:solidFill>
-                <a:latin typeface="Inter" pitchFamily="34" charset="0"/>
-                <a:ea typeface="Inter" pitchFamily="34" charset="-122"/>
-                <a:cs typeface="Inter" pitchFamily="34" charset="-120"/>
-              </a:rPr>
-              <a:t>+5.6 pts</a:t>
-            </a:r>
-            <a:endParaRPr lang="en-US" sz="1600" dirty="0"/>
+            <a:endParaRPr lang="en-US" sz="1800" dirty="0"/>
           </a:p>
         </p:txBody>
       </p:sp>

</xml_diff>